<commit_message>
Mark business case as illustrative; add revenue and review outcomes
Co-Authored-By: Claude Opus 5.5 <noreply@anthropic.com>
Claude-Session: https://claude.ai/code/session_016ZGbiuM9ffruZKrFMKYq5D
</commit_message>
<xml_diff>
--- a/Patientcurve-Proposal-Dr-Mohanapriya.pptx
+++ b/Patientcurve-Proposal-Dr-Mohanapriya.pptx
@@ -114,30 +114,30 @@
   <p:extLst>
     <p:ext uri="{521415D9-36F7-43E2-AB2F-B90AF26B5E84}">
       <p14:sectionLst xmlns:p14="http://schemas.microsoft.com/office/powerpoint/2010/main">
-        <p14:section name="Introduction" id="{2b479497-4a54-8564-56c0-e338868688c3}">
+        <p14:section name="Introduction" id="{07964782-521c-9233-8560-5dfa54f73950}">
           <p14:sldIdLst>
             <p14:sldId id="256"/>
           </p14:sldIdLst>
         </p14:section>
-        <p14:section name="The opportunity" id="{bf110550-1610-7a71-ae3b-1104a36b5c65}">
+        <p14:section name="The opportunity" id="{daa59b9b-d290-98c8-90ea-8e79b2285339}">
           <p14:sldIdLst>
             <p14:sldId id="257"/>
           </p14:sldIdLst>
         </p14:section>
-        <p14:section name="The solution" id="{bd8e9e4a-e021-faa7-1f54-1e0210502413}">
+        <p14:section name="The solution" id="{ac8f45e7-3f41-cbea-58ad-04cf2ada8976}">
           <p14:sldIdLst>
             <p14:sldId id="258"/>
             <p14:sldId id="259"/>
           </p14:sldIdLst>
         </p14:section>
-        <p14:section name="Investment" id="{aed2dfb7-c922-1b9d-5a30-2216d0240525}">
+        <p14:section name="Investment" id="{7bd56e07-a59c-8db6-0d40-8a1b554ea82b}">
           <p14:sldIdLst>
             <p14:sldId id="260"/>
             <p14:sldId id="261"/>
             <p14:sldId id="262"/>
           </p14:sldIdLst>
         </p14:section>
-        <p14:section name="The decision" id="{a3e2ba84-3aa6-77ad-6fc0-72d6d8d06511}">
+        <p14:section name="The decision" id="{9ffcba34-d3ac-ceba-96eb-0251c232f5be}">
           <p14:sldIdLst>
             <p14:sldId id="263"/>
           </p14:sldIdLst>
@@ -986,7 +986,7 @@
           <a:p>
             <a:r>
               <a:rPr lang="en-US" dirty="0"/>
-              <a:t>Only the 100 enquiries comes from the clinic. The other inputs are examples to replace with her real numbers. At these figures, 60 enquiries a month don't book; bringing back 20% of them is 12 patients, about ₹96,000 a month, and a single patient brought back covers the ₹2,999 fee.</a:t>
+              <a:t>Stress that this is an illustrative scenario, not a forecast: actual results depend on patient conversion, treatment uptake and average treatment value. Only the 100 enquiries comes from the clinic. The other inputs are examples to replace with her real numbers. At these figures, 60 enquiries a month don't book; bringing back 20% of them is 12 patients, about ₹96,000 a month, and a single patient brought back covers the ₹2,999 fee.</a:t>
             </a:r>
             <a:endParaRPr lang="en-US" dirty="0"/>
           </a:p>
@@ -5076,11 +5076,11 @@
         <p:spPr>
           <a:xfrm>
             <a:off x="548640" y="1600200"/>
-            <a:ext cx="3566160" cy="2788920"/>
+            <a:ext cx="3566160" cy="3017520"/>
           </a:xfrm>
           <a:prstGeom prst="roundRect">
             <a:avLst>
-              <a:gd name="adj" fmla="val 3934"/>
+              <a:gd name="adj" fmla="val 3636"/>
             </a:avLst>
           </a:prstGeom>
           <a:solidFill>
@@ -5162,8 +5162,8 @@
         </p:nvSpPr>
         <p:spPr>
           <a:xfrm>
-            <a:off x="822960" y="2468880"/>
-            <a:ext cx="3108960" cy="1828800"/>
+            <a:off x="822960" y="2423160"/>
+            <a:ext cx="3108960" cy="2103120"/>
           </a:xfrm>
           <a:prstGeom prst="rect">
             <a:avLst/>
@@ -5238,7 +5238,7 @@
         </p:nvSpPr>
         <p:spPr>
           <a:xfrm>
-            <a:off x="4114800" y="2994660"/>
+            <a:off x="4114800" y="3108960"/>
             <a:ext cx="182880" cy="0"/>
           </a:xfrm>
           <a:prstGeom prst="line">
@@ -5263,11 +5263,11 @@
         <p:spPr>
           <a:xfrm>
             <a:off x="4297680" y="1600200"/>
-            <a:ext cx="3566160" cy="2788920"/>
+            <a:ext cx="3566160" cy="3017520"/>
           </a:xfrm>
           <a:prstGeom prst="roundRect">
             <a:avLst>
-              <a:gd name="adj" fmla="val 3934"/>
+              <a:gd name="adj" fmla="val 3636"/>
             </a:avLst>
           </a:prstGeom>
           <a:solidFill>
@@ -5349,8 +5349,8 @@
         </p:nvSpPr>
         <p:spPr>
           <a:xfrm>
-            <a:off x="4572000" y="2468880"/>
-            <a:ext cx="3108960" cy="1828800"/>
+            <a:off x="4572000" y="2423160"/>
+            <a:ext cx="3108960" cy="2103120"/>
           </a:xfrm>
           <a:prstGeom prst="rect">
             <a:avLst/>
@@ -5425,7 +5425,7 @@
         </p:nvSpPr>
         <p:spPr>
           <a:xfrm>
-            <a:off x="7863840" y="2994660"/>
+            <a:off x="7863840" y="3108960"/>
             <a:ext cx="182880" cy="0"/>
           </a:xfrm>
           <a:prstGeom prst="line">
@@ -5450,11 +5450,11 @@
         <p:spPr>
           <a:xfrm>
             <a:off x="8046720" y="1600200"/>
-            <a:ext cx="3566160" cy="2788920"/>
+            <a:ext cx="3566160" cy="3017520"/>
           </a:xfrm>
           <a:prstGeom prst="roundRect">
             <a:avLst>
-              <a:gd name="adj" fmla="val 3934"/>
+              <a:gd name="adj" fmla="val 3636"/>
             </a:avLst>
           </a:prstGeom>
           <a:solidFill>
@@ -5536,8 +5536,8 @@
         </p:nvSpPr>
         <p:spPr>
           <a:xfrm>
-            <a:off x="8321040" y="2468880"/>
-            <a:ext cx="3108960" cy="1828800"/>
+            <a:off x="8321040" y="2423160"/>
+            <a:ext cx="3108960" cy="2103120"/>
           </a:xfrm>
           <a:prstGeom prst="rect">
             <a:avLst/>
@@ -5602,6 +5602,24 @@
             </a:r>
             <a:endParaRPr lang="en-US" sz="1300" dirty="0"/>
           </a:p>
+          <a:p>
+            <a:pPr marL="342900" indent="-342900">
+              <a:spcAft>
+                <a:spcPts val="800"/>
+              </a:spcAft>
+              <a:buSzPct val="100000"/>
+              <a:buChar char="•"/>
+            </a:pPr>
+            <a:r>
+              <a:rPr lang="en-US" sz="1300" dirty="0">
+                <a:solidFill>
+                  <a:schemeClr val="tx1"/>
+                </a:solidFill>
+              </a:rPr>
+              <a:t>After each visit, a review request: positive reviews go to Google, negative feedback to your inbox</a:t>
+            </a:r>
+            <a:endParaRPr lang="en-US" sz="1300" dirty="0"/>
+          </a:p>
         </p:txBody>
       </p:sp>
       <p:sp>
@@ -5612,12 +5630,12 @@
         </p:nvSpPr>
         <p:spPr>
           <a:xfrm>
-            <a:off x="548640" y="4572000"/>
-            <a:ext cx="5468112" cy="1463040"/>
+            <a:off x="548640" y="4754880"/>
+            <a:ext cx="5468112" cy="1280160"/>
           </a:xfrm>
           <a:prstGeom prst="roundRect">
             <a:avLst>
-              <a:gd name="adj" fmla="val 7500"/>
+              <a:gd name="adj" fmla="val 8571"/>
             </a:avLst>
           </a:prstGeom>
           <a:solidFill>
@@ -5634,7 +5652,7 @@
         </p:nvSpPr>
         <p:spPr>
           <a:xfrm>
-            <a:off x="822960" y="4754880"/>
+            <a:off x="822960" y="4919472"/>
             <a:ext cx="4572000" cy="274320"/>
           </a:xfrm>
           <a:prstGeom prst="rect">
@@ -5670,8 +5688,8 @@
         </p:nvSpPr>
         <p:spPr>
           <a:xfrm>
-            <a:off x="822960" y="5074920"/>
-            <a:ext cx="4983480" cy="868680"/>
+            <a:off x="822960" y="5230368"/>
+            <a:ext cx="4983480" cy="731520"/>
           </a:xfrm>
           <a:prstGeom prst="rect">
             <a:avLst/>
@@ -5706,12 +5724,12 @@
         </p:nvSpPr>
         <p:spPr>
           <a:xfrm>
-            <a:off x="6172200" y="4572000"/>
-            <a:ext cx="5468112" cy="1463040"/>
+            <a:off x="6172200" y="4754880"/>
+            <a:ext cx="5468112" cy="1280160"/>
           </a:xfrm>
           <a:prstGeom prst="roundRect">
             <a:avLst>
-              <a:gd name="adj" fmla="val 7500"/>
+              <a:gd name="adj" fmla="val 8571"/>
             </a:avLst>
           </a:prstGeom>
           <a:solidFill>
@@ -5728,7 +5746,7 @@
         </p:nvSpPr>
         <p:spPr>
           <a:xfrm>
-            <a:off x="6446520" y="4754880"/>
+            <a:off x="6446520" y="4919472"/>
             <a:ext cx="4572000" cy="274320"/>
           </a:xfrm>
           <a:prstGeom prst="rect">
@@ -5764,8 +5782,8 @@
         </p:nvSpPr>
         <p:spPr>
           <a:xfrm>
-            <a:off x="6446520" y="5074920"/>
-            <a:ext cx="4983480" cy="868680"/>
+            <a:off x="6446520" y="5230368"/>
+            <a:ext cx="4983480" cy="731520"/>
           </a:xfrm>
           <a:prstGeom prst="rect">
             <a:avLst/>
@@ -6553,6 +6571,24 @@
                   <a:schemeClr val="bg1"/>
                 </a:solidFill>
               </a:rPr>
+              <a:t>Review requests after every visit</a:t>
+            </a:r>
+            <a:endParaRPr lang="en-US" sz="1300" dirty="0"/>
+          </a:p>
+          <a:p>
+            <a:pPr marL="342900" indent="-342900">
+              <a:spcAft>
+                <a:spcPts val="400"/>
+              </a:spcAft>
+              <a:buSzPct val="100000"/>
+              <a:buChar char="•"/>
+            </a:pPr>
+            <a:r>
+              <a:rPr lang="en-US" sz="1300" dirty="0">
+                <a:solidFill>
+                  <a:schemeClr val="bg1"/>
+                </a:solidFill>
+              </a:rPr>
               <a:t>Hosting, monitoring and updates</a:t>
             </a:r>
             <a:endParaRPr lang="en-US" sz="1300" dirty="0"/>
@@ -6749,8 +6785,8 @@
         </p:nvSpPr>
         <p:spPr>
           <a:xfrm>
-            <a:off x="548640" y="1691640"/>
-            <a:ext cx="5577840" cy="1371600"/>
+            <a:off x="548640" y="2286000"/>
+            <a:ext cx="5577840" cy="1143000"/>
           </a:xfrm>
           <a:prstGeom prst="rect">
             <a:avLst/>
@@ -6824,13 +6860,111 @@
       </p:sp>
       <p:sp>
         <p:nvSpPr>
-          <p:cNvPr id="5" name="Shape 3"/>
+          <p:cNvPr id="5" name="illustrative-notice"/>
           <p:cNvSpPr/>
           <p:nvPr/>
         </p:nvSpPr>
         <p:spPr>
           <a:xfrm>
-            <a:off x="548640" y="3154680"/>
+            <a:off x="548640" y="1463040"/>
+            <a:ext cx="11091672" cy="640080"/>
+          </a:xfrm>
+          <a:prstGeom prst="roundRect">
+            <a:avLst>
+              <a:gd name="adj" fmla="val 14286"/>
+            </a:avLst>
+          </a:prstGeom>
+          <a:solidFill>
+            <a:schemeClr val="bg1"/>
+          </a:solidFill>
+          <a:ln w="15875">
+            <a:solidFill>
+              <a:schemeClr val="accent3"/>
+            </a:solidFill>
+            <a:prstDash val="solid"/>
+          </a:ln>
+        </p:spPr>
+      </p:sp>
+      <p:pic>
+        <p:nvPicPr>
+          <p:cNvPr id="6" name="Image 0" descr="preencoded.png">    </p:cNvPr>
+          <p:cNvPicPr>
+            <a:picLocks noChangeAspect="1"/>
+          </p:cNvPicPr>
+          <p:nvPr/>
+        </p:nvPicPr>
+        <p:blipFill>
+          <a:blip r:embed="rId1"/>
+          <a:stretch>
+            <a:fillRect/>
+          </a:stretch>
+        </p:blipFill>
+        <p:spPr>
+          <a:xfrm>
+            <a:off x="777240" y="1600200"/>
+            <a:ext cx="365760" cy="365760"/>
+          </a:xfrm>
+          <a:prstGeom prst="rect">
+            <a:avLst/>
+          </a:prstGeom>
+        </p:spPr>
+      </p:pic>
+      <p:sp>
+        <p:nvSpPr>
+          <p:cNvPr id="7" name="Text 4"/>
+          <p:cNvSpPr txBox="1"/>
+          <p:nvPr/>
+        </p:nvSpPr>
+        <p:spPr>
+          <a:xfrm>
+            <a:off x="1325880" y="1463040"/>
+            <a:ext cx="10149840" cy="640080"/>
+          </a:xfrm>
+          <a:prstGeom prst="rect">
+            <a:avLst/>
+          </a:prstGeom>
+          <a:noFill/>
+          <a:ln/>
+        </p:spPr>
+        <p:txBody>
+          <a:bodyPr wrap="square" lIns="0" tIns="0" rIns="0" bIns="0" rtlCol="0" anchor="ctr"/>
+          <a:lstStyle/>
+          <a:p>
+            <a:pPr indent="0" marL="0">
+              <a:buNone/>
+            </a:pPr>
+            <a:r>
+              <a:rPr lang="en-US" sz="1400" b="1" dirty="0">
+                <a:solidFill>
+                  <a:schemeClr val="accent3"/>
+                </a:solidFill>
+              </a:rPr>
+              <a:t>Illustrative scenario only.  </a:t>
+            </a:r>
+            <a:pPr indent="0" marL="0">
+              <a:buNone/>
+            </a:pPr>
+            <a:r>
+              <a:rPr lang="en-US" sz="1400" dirty="0">
+                <a:solidFill>
+                  <a:schemeClr val="tx1"/>
+                </a:solidFill>
+              </a:rPr>
+              <a:t>Actual results depend on patient conversion, treatment uptake and average treatment value. These figures are not a revenue forecast.</a:t>
+            </a:r>
+            <a:endParaRPr lang="en-US" sz="1400" dirty="0"/>
+          </a:p>
+        </p:txBody>
+      </p:sp>
+      <p:sp>
+        <p:nvSpPr>
+          <p:cNvPr id="8" name="Shape 5"/>
+          <p:cNvSpPr/>
+          <p:nvPr/>
+        </p:nvSpPr>
+        <p:spPr>
+          <a:xfrm>
+            <a:off x="548640" y="3474720"/>
             <a:ext cx="1005840" cy="274320"/>
           </a:xfrm>
           <a:prstGeom prst="roundRect">
@@ -6851,13 +6985,13 @@
       </p:sp>
       <p:sp>
         <p:nvSpPr>
-          <p:cNvPr id="6" name="Text 4"/>
+          <p:cNvPr id="9" name="Text 6"/>
           <p:cNvSpPr txBox="1"/>
           <p:nvPr/>
         </p:nvSpPr>
         <p:spPr>
           <a:xfrm>
-            <a:off x="548640" y="3154680"/>
+            <a:off x="548640" y="3474720"/>
             <a:ext cx="1005840" cy="274320"/>
           </a:xfrm>
           <a:prstGeom prst="rect">
@@ -6890,13 +7024,13 @@
       </p:sp>
       <p:sp>
         <p:nvSpPr>
-          <p:cNvPr id="7" name="Text 5"/>
+          <p:cNvPr id="10" name="Text 7"/>
           <p:cNvSpPr txBox="1"/>
           <p:nvPr/>
         </p:nvSpPr>
         <p:spPr>
           <a:xfrm>
-            <a:off x="1691640" y="3154680"/>
+            <a:off x="1691640" y="3474720"/>
             <a:ext cx="4114800" cy="274320"/>
           </a:xfrm>
           <a:prstGeom prst="rect">
@@ -6939,7 +7073,7 @@
           </p:nvPr>
         </p:nvGraphicFramePr>
         <p:xfrm>
-          <a:off x="548640" y="3566160"/>
+          <a:off x="548640" y="3840480"/>
           <a:ext cx="5577840" cy="914400"/>
         </p:xfrm>
         <a:graphic>
@@ -6950,7 +7084,7 @@
                 <a:gridCol w="3749040"/>
                 <a:gridCol w="1828800"/>
               </a:tblGrid>
-              <a:tr h="347472">
+              <a:tr h="310896">
                 <a:tc>
                   <a:txBody>
                     <a:bodyPr/>
@@ -7038,7 +7172,7 @@
                   </a:tcPr>
                 </a:tc>
               </a:tr>
-              <a:tr h="347472">
+              <a:tr h="310896">
                 <a:tc>
                   <a:txBody>
                     <a:bodyPr/>
@@ -7126,7 +7260,7 @@
                   </a:tcPr>
                 </a:tc>
               </a:tr>
-              <a:tr h="347472">
+              <a:tr h="310896">
                 <a:tc>
                   <a:txBody>
                     <a:bodyPr/>
@@ -7214,7 +7348,7 @@
                   </a:tcPr>
                 </a:tc>
               </a:tr>
-              <a:tr h="347472">
+              <a:tr h="310896">
                 <a:tc>
                   <a:txBody>
                     <a:bodyPr/>
@@ -7302,7 +7436,7 @@
                   </a:tcPr>
                 </a:tc>
               </a:tr>
-              <a:tr h="347472">
+              <a:tr h="310896">
                 <a:tc>
                   <a:txBody>
                     <a:bodyPr/>
@@ -7390,7 +7524,7 @@
                   </a:tcPr>
                 </a:tc>
               </a:tr>
-              <a:tr h="347472">
+              <a:tr h="310896">
                 <a:tc>
                   <a:txBody>
                     <a:bodyPr/>
@@ -7484,18 +7618,18 @@
       </p:graphicFrame>
       <p:sp>
         <p:nvSpPr>
-          <p:cNvPr id="9" name="tile-0"/>
+          <p:cNvPr id="12" name="tile-0"/>
           <p:cNvSpPr/>
           <p:nvPr/>
         </p:nvSpPr>
         <p:spPr>
           <a:xfrm>
-            <a:off x="6583680" y="1691640"/>
-            <a:ext cx="2423160" cy="1737360"/>
+            <a:off x="6583680" y="2286000"/>
+            <a:ext cx="2423160" cy="1645920"/>
           </a:xfrm>
           <a:prstGeom prst="roundRect">
             <a:avLst>
-              <a:gd name="adj" fmla="val 6316"/>
+              <a:gd name="adj" fmla="val 6667"/>
             </a:avLst>
           </a:prstGeom>
           <a:solidFill>
@@ -7511,13 +7645,49 @@
       </p:sp>
       <p:sp>
         <p:nvSpPr>
-          <p:cNvPr id="10" name="Text 7"/>
+          <p:cNvPr id="13" name="Text 9"/>
           <p:cNvSpPr txBox="1"/>
           <p:nvPr/>
         </p:nvSpPr>
         <p:spPr>
           <a:xfrm>
-            <a:off x="6812280" y="1892808"/>
+            <a:off x="6812280" y="2450592"/>
+            <a:ext cx="2011680" cy="640080"/>
+          </a:xfrm>
+          <a:prstGeom prst="rect">
+            <a:avLst/>
+          </a:prstGeom>
+          <a:noFill/>
+          <a:ln/>
+        </p:spPr>
+        <p:txBody>
+          <a:bodyPr wrap="square" lIns="0" tIns="0" rIns="0" bIns="0" rtlCol="0" anchor="b"/>
+          <a:lstStyle/>
+          <a:p>
+            <a:pPr indent="0" marL="0">
+              <a:buNone/>
+            </a:pPr>
+            <a:r>
+              <a:rPr lang="en-US" sz="3000" b="1" dirty="0">
+                <a:solidFill>
+                  <a:schemeClr val="tx1"/>
+                </a:solidFill>
+              </a:rPr>
+              <a:t>60</a:t>
+            </a:r>
+            <a:endParaRPr lang="en-US" sz="3000" dirty="0"/>
+          </a:p>
+        </p:txBody>
+      </p:sp>
+      <p:sp>
+        <p:nvSpPr>
+          <p:cNvPr id="14" name="Text 10"/>
+          <p:cNvSpPr txBox="1"/>
+          <p:nvPr/>
+        </p:nvSpPr>
+        <p:spPr>
+          <a:xfrm>
+            <a:off x="6812280" y="3154680"/>
             <a:ext cx="2011680" cy="685800"/>
           </a:xfrm>
           <a:prstGeom prst="rect">
@@ -7527,49 +7697,13 @@
           <a:ln/>
         </p:spPr>
         <p:txBody>
-          <a:bodyPr wrap="square" lIns="0" tIns="0" rIns="0" bIns="0" rtlCol="0" anchor="b"/>
+          <a:bodyPr wrap="square" lIns="0" tIns="0" rIns="0" bIns="0" rtlCol="0" anchor="t"/>
           <a:lstStyle/>
           <a:p>
             <a:pPr indent="0" marL="0">
               <a:buNone/>
             </a:pPr>
             <a:r>
-              <a:rPr lang="en-US" sz="3000" b="1" dirty="0">
-                <a:solidFill>
-                  <a:schemeClr val="tx1"/>
-                </a:solidFill>
-              </a:rPr>
-              <a:t>60</a:t>
-            </a:r>
-            <a:endParaRPr lang="en-US" sz="3000" dirty="0"/>
-          </a:p>
-        </p:txBody>
-      </p:sp>
-      <p:sp>
-        <p:nvSpPr>
-          <p:cNvPr id="11" name="Text 8"/>
-          <p:cNvSpPr txBox="1"/>
-          <p:nvPr/>
-        </p:nvSpPr>
-        <p:spPr>
-          <a:xfrm>
-            <a:off x="6812280" y="2624328"/>
-            <a:ext cx="2011680" cy="731520"/>
-          </a:xfrm>
-          <a:prstGeom prst="rect">
-            <a:avLst/>
-          </a:prstGeom>
-          <a:noFill/>
-          <a:ln/>
-        </p:spPr>
-        <p:txBody>
-          <a:bodyPr wrap="square" lIns="0" tIns="0" rIns="0" bIns="0" rtlCol="0" anchor="t"/>
-          <a:lstStyle/>
-          <a:p>
-            <a:pPr indent="0" marL="0">
-              <a:buNone/>
-            </a:pPr>
-            <a:r>
               <a:rPr lang="en-US" sz="1200" dirty="0">
                 <a:solidFill>
                   <a:schemeClr val="tx2"/>
@@ -7583,18 +7717,18 @@
       </p:sp>
       <p:sp>
         <p:nvSpPr>
-          <p:cNvPr id="12" name="tile-1"/>
+          <p:cNvPr id="15" name="tile-1"/>
           <p:cNvSpPr/>
           <p:nvPr/>
         </p:nvSpPr>
         <p:spPr>
           <a:xfrm>
-            <a:off x="9144000" y="1691640"/>
-            <a:ext cx="2423160" cy="1737360"/>
+            <a:off x="9144000" y="2286000"/>
+            <a:ext cx="2423160" cy="1645920"/>
           </a:xfrm>
           <a:prstGeom prst="roundRect">
             <a:avLst>
-              <a:gd name="adj" fmla="val 6316"/>
+              <a:gd name="adj" fmla="val 6667"/>
             </a:avLst>
           </a:prstGeom>
           <a:solidFill>
@@ -7610,13 +7744,49 @@
       </p:sp>
       <p:sp>
         <p:nvSpPr>
-          <p:cNvPr id="13" name="Text 10"/>
+          <p:cNvPr id="16" name="Text 12"/>
           <p:cNvSpPr txBox="1"/>
           <p:nvPr/>
         </p:nvSpPr>
         <p:spPr>
           <a:xfrm>
-            <a:off x="9372600" y="1892808"/>
+            <a:off x="9372600" y="2450592"/>
+            <a:ext cx="2011680" cy="640080"/>
+          </a:xfrm>
+          <a:prstGeom prst="rect">
+            <a:avLst/>
+          </a:prstGeom>
+          <a:noFill/>
+          <a:ln/>
+        </p:spPr>
+        <p:txBody>
+          <a:bodyPr wrap="square" lIns="0" tIns="0" rIns="0" bIns="0" rtlCol="0" anchor="b"/>
+          <a:lstStyle/>
+          <a:p>
+            <a:pPr indent="0" marL="0">
+              <a:buNone/>
+            </a:pPr>
+            <a:r>
+              <a:rPr lang="en-US" sz="3000" b="1" dirty="0">
+                <a:solidFill>
+                  <a:schemeClr val="tx1"/>
+                </a:solidFill>
+              </a:rPr>
+              <a:t>₹8,000</a:t>
+            </a:r>
+            <a:endParaRPr lang="en-US" sz="3000" dirty="0"/>
+          </a:p>
+        </p:txBody>
+      </p:sp>
+      <p:sp>
+        <p:nvSpPr>
+          <p:cNvPr id="17" name="Text 13"/>
+          <p:cNvSpPr txBox="1"/>
+          <p:nvPr/>
+        </p:nvSpPr>
+        <p:spPr>
+          <a:xfrm>
+            <a:off x="9372600" y="3154680"/>
             <a:ext cx="2011680" cy="685800"/>
           </a:xfrm>
           <a:prstGeom prst="rect">
@@ -7626,49 +7796,13 @@
           <a:ln/>
         </p:spPr>
         <p:txBody>
-          <a:bodyPr wrap="square" lIns="0" tIns="0" rIns="0" bIns="0" rtlCol="0" anchor="b"/>
+          <a:bodyPr wrap="square" lIns="0" tIns="0" rIns="0" bIns="0" rtlCol="0" anchor="t"/>
           <a:lstStyle/>
           <a:p>
             <a:pPr indent="0" marL="0">
               <a:buNone/>
             </a:pPr>
             <a:r>
-              <a:rPr lang="en-US" sz="3000" b="1" dirty="0">
-                <a:solidFill>
-                  <a:schemeClr val="tx1"/>
-                </a:solidFill>
-              </a:rPr>
-              <a:t>₹8,000</a:t>
-            </a:r>
-            <a:endParaRPr lang="en-US" sz="3000" dirty="0"/>
-          </a:p>
-        </p:txBody>
-      </p:sp>
-      <p:sp>
-        <p:nvSpPr>
-          <p:cNvPr id="14" name="Text 11"/>
-          <p:cNvSpPr txBox="1"/>
-          <p:nvPr/>
-        </p:nvSpPr>
-        <p:spPr>
-          <a:xfrm>
-            <a:off x="9372600" y="2624328"/>
-            <a:ext cx="2011680" cy="731520"/>
-          </a:xfrm>
-          <a:prstGeom prst="rect">
-            <a:avLst/>
-          </a:prstGeom>
-          <a:noFill/>
-          <a:ln/>
-        </p:spPr>
-        <p:txBody>
-          <a:bodyPr wrap="square" lIns="0" tIns="0" rIns="0" bIns="0" rtlCol="0" anchor="t"/>
-          <a:lstStyle/>
-          <a:p>
-            <a:pPr indent="0" marL="0">
-              <a:buNone/>
-            </a:pPr>
-            <a:r>
               <a:rPr lang="en-US" sz="1200" dirty="0">
                 <a:solidFill>
                   <a:schemeClr val="tx2"/>
@@ -7682,18 +7816,18 @@
       </p:sp>
       <p:sp>
         <p:nvSpPr>
-          <p:cNvPr id="15" name="tile-2"/>
+          <p:cNvPr id="18" name="tile-2"/>
           <p:cNvSpPr/>
           <p:nvPr/>
         </p:nvSpPr>
         <p:spPr>
           <a:xfrm>
-            <a:off x="6583680" y="3611880"/>
-            <a:ext cx="2423160" cy="1737360"/>
+            <a:off x="6583680" y="4096512"/>
+            <a:ext cx="2423160" cy="1645920"/>
           </a:xfrm>
           <a:prstGeom prst="roundRect">
             <a:avLst>
-              <a:gd name="adj" fmla="val 6316"/>
+              <a:gd name="adj" fmla="val 6667"/>
             </a:avLst>
           </a:prstGeom>
           <a:solidFill>
@@ -7709,13 +7843,49 @@
       </p:sp>
       <p:sp>
         <p:nvSpPr>
-          <p:cNvPr id="16" name="Text 13"/>
+          <p:cNvPr id="19" name="Text 15"/>
           <p:cNvSpPr txBox="1"/>
           <p:nvPr/>
         </p:nvSpPr>
         <p:spPr>
           <a:xfrm>
-            <a:off x="6812280" y="3813048"/>
+            <a:off x="6812280" y="4261104"/>
+            <a:ext cx="2011680" cy="640080"/>
+          </a:xfrm>
+          <a:prstGeom prst="rect">
+            <a:avLst/>
+          </a:prstGeom>
+          <a:noFill/>
+          <a:ln/>
+        </p:spPr>
+        <p:txBody>
+          <a:bodyPr wrap="square" lIns="0" tIns="0" rIns="0" bIns="0" rtlCol="0" anchor="b"/>
+          <a:lstStyle/>
+          <a:p>
+            <a:pPr indent="0" marL="0">
+              <a:buNone/>
+            </a:pPr>
+            <a:r>
+              <a:rPr lang="en-US" sz="3000" b="1" dirty="0">
+                <a:solidFill>
+                  <a:schemeClr val="tx1"/>
+                </a:solidFill>
+              </a:rPr>
+              <a:t>₹96,000</a:t>
+            </a:r>
+            <a:endParaRPr lang="en-US" sz="3000" dirty="0"/>
+          </a:p>
+        </p:txBody>
+      </p:sp>
+      <p:sp>
+        <p:nvSpPr>
+          <p:cNvPr id="20" name="Text 16"/>
+          <p:cNvSpPr txBox="1"/>
+          <p:nvPr/>
+        </p:nvSpPr>
+        <p:spPr>
+          <a:xfrm>
+            <a:off x="6812280" y="4965192"/>
             <a:ext cx="2011680" cy="685800"/>
           </a:xfrm>
           <a:prstGeom prst="rect">
@@ -7725,49 +7895,13 @@
           <a:ln/>
         </p:spPr>
         <p:txBody>
-          <a:bodyPr wrap="square" lIns="0" tIns="0" rIns="0" bIns="0" rtlCol="0" anchor="b"/>
+          <a:bodyPr wrap="square" lIns="0" tIns="0" rIns="0" bIns="0" rtlCol="0" anchor="t"/>
           <a:lstStyle/>
           <a:p>
             <a:pPr indent="0" marL="0">
               <a:buNone/>
             </a:pPr>
             <a:r>
-              <a:rPr lang="en-US" sz="3000" b="1" dirty="0">
-                <a:solidFill>
-                  <a:schemeClr val="tx1"/>
-                </a:solidFill>
-              </a:rPr>
-              <a:t>₹96,000</a:t>
-            </a:r>
-            <a:endParaRPr lang="en-US" sz="3000" dirty="0"/>
-          </a:p>
-        </p:txBody>
-      </p:sp>
-      <p:sp>
-        <p:nvSpPr>
-          <p:cNvPr id="17" name="Text 14"/>
-          <p:cNvSpPr txBox="1"/>
-          <p:nvPr/>
-        </p:nvSpPr>
-        <p:spPr>
-          <a:xfrm>
-            <a:off x="6812280" y="4544568"/>
-            <a:ext cx="2011680" cy="731520"/>
-          </a:xfrm>
-          <a:prstGeom prst="rect">
-            <a:avLst/>
-          </a:prstGeom>
-          <a:noFill/>
-          <a:ln/>
-        </p:spPr>
-        <p:txBody>
-          <a:bodyPr wrap="square" lIns="0" tIns="0" rIns="0" bIns="0" rtlCol="0" anchor="t"/>
-          <a:lstStyle/>
-          <a:p>
-            <a:pPr indent="0" marL="0">
-              <a:buNone/>
-            </a:pPr>
-            <a:r>
               <a:rPr lang="en-US" sz="1200" dirty="0">
                 <a:solidFill>
                   <a:schemeClr val="tx2"/>
@@ -7781,18 +7915,18 @@
       </p:sp>
       <p:sp>
         <p:nvSpPr>
-          <p:cNvPr id="18" name="tile-3"/>
+          <p:cNvPr id="21" name="tile-3"/>
           <p:cNvSpPr/>
           <p:nvPr/>
         </p:nvSpPr>
         <p:spPr>
           <a:xfrm>
-            <a:off x="9144000" y="3611880"/>
-            <a:ext cx="2423160" cy="1737360"/>
+            <a:off x="9144000" y="4096512"/>
+            <a:ext cx="2423160" cy="1645920"/>
           </a:xfrm>
           <a:prstGeom prst="roundRect">
             <a:avLst>
-              <a:gd name="adj" fmla="val 6316"/>
+              <a:gd name="adj" fmla="val 6667"/>
             </a:avLst>
           </a:prstGeom>
           <a:solidFill>
@@ -7803,13 +7937,49 @@
       </p:sp>
       <p:sp>
         <p:nvSpPr>
-          <p:cNvPr id="19" name="Text 16"/>
+          <p:cNvPr id="22" name="Text 18"/>
           <p:cNvSpPr txBox="1"/>
           <p:nvPr/>
         </p:nvSpPr>
         <p:spPr>
           <a:xfrm>
-            <a:off x="9372600" y="3813048"/>
+            <a:off x="9372600" y="4261104"/>
+            <a:ext cx="2011680" cy="640080"/>
+          </a:xfrm>
+          <a:prstGeom prst="rect">
+            <a:avLst/>
+          </a:prstGeom>
+          <a:noFill/>
+          <a:ln/>
+        </p:spPr>
+        <p:txBody>
+          <a:bodyPr wrap="square" lIns="0" tIns="0" rIns="0" bIns="0" rtlCol="0" anchor="b"/>
+          <a:lstStyle/>
+          <a:p>
+            <a:pPr indent="0" marL="0">
+              <a:buNone/>
+            </a:pPr>
+            <a:r>
+              <a:rPr lang="en-US" sz="3000" b="1" dirty="0">
+                <a:solidFill>
+                  <a:schemeClr val="bg1"/>
+                </a:solidFill>
+              </a:rPr>
+              <a:t>1 patient</a:t>
+            </a:r>
+            <a:endParaRPr lang="en-US" sz="3000" dirty="0"/>
+          </a:p>
+        </p:txBody>
+      </p:sp>
+      <p:sp>
+        <p:nvSpPr>
+          <p:cNvPr id="23" name="Text 19"/>
+          <p:cNvSpPr txBox="1"/>
+          <p:nvPr/>
+        </p:nvSpPr>
+        <p:spPr>
+          <a:xfrm>
+            <a:off x="9372600" y="4965192"/>
             <a:ext cx="2011680" cy="685800"/>
           </a:xfrm>
           <a:prstGeom prst="rect">
@@ -7819,93 +7989,21 @@
           <a:ln/>
         </p:spPr>
         <p:txBody>
-          <a:bodyPr wrap="square" lIns="0" tIns="0" rIns="0" bIns="0" rtlCol="0" anchor="b"/>
+          <a:bodyPr wrap="square" lIns="0" tIns="0" rIns="0" bIns="0" rtlCol="0" anchor="t"/>
           <a:lstStyle/>
           <a:p>
             <a:pPr indent="0" marL="0">
               <a:buNone/>
             </a:pPr>
             <a:r>
-              <a:rPr lang="en-US" sz="3000" b="1" dirty="0">
+              <a:rPr lang="en-US" sz="1200" dirty="0">
                 <a:solidFill>
                   <a:schemeClr val="bg1"/>
                 </a:solidFill>
               </a:rPr>
-              <a:t>1 patient</a:t>
-            </a:r>
-            <a:endParaRPr lang="en-US" sz="3000" dirty="0"/>
-          </a:p>
-        </p:txBody>
-      </p:sp>
-      <p:sp>
-        <p:nvSpPr>
-          <p:cNvPr id="20" name="Text 17"/>
-          <p:cNvSpPr txBox="1"/>
-          <p:nvPr/>
-        </p:nvSpPr>
-        <p:spPr>
-          <a:xfrm>
-            <a:off x="9372600" y="4544568"/>
-            <a:ext cx="2011680" cy="731520"/>
-          </a:xfrm>
-          <a:prstGeom prst="rect">
-            <a:avLst/>
-          </a:prstGeom>
-          <a:noFill/>
-          <a:ln/>
-        </p:spPr>
-        <p:txBody>
-          <a:bodyPr wrap="square" lIns="0" tIns="0" rIns="0" bIns="0" rtlCol="0" anchor="t"/>
-          <a:lstStyle/>
-          <a:p>
-            <a:pPr indent="0" marL="0">
-              <a:buNone/>
-            </a:pPr>
-            <a:r>
-              <a:rPr lang="en-US" sz="1200" dirty="0">
-                <a:solidFill>
-                  <a:schemeClr val="bg1"/>
-                </a:solidFill>
-              </a:rPr>
               <a:t>a month covers the ₹2,999 fee</a:t>
             </a:r>
             <a:endParaRPr lang="en-US" sz="1200" dirty="0"/>
-          </a:p>
-        </p:txBody>
-      </p:sp>
-      <p:sp>
-        <p:nvSpPr>
-          <p:cNvPr id="21" name="Text 18"/>
-          <p:cNvSpPr txBox="1"/>
-          <p:nvPr/>
-        </p:nvSpPr>
-        <p:spPr>
-          <a:xfrm>
-            <a:off x="6583680" y="5577840"/>
-            <a:ext cx="5029200" cy="457200"/>
-          </a:xfrm>
-          <a:prstGeom prst="rect">
-            <a:avLst/>
-          </a:prstGeom>
-          <a:noFill/>
-          <a:ln/>
-        </p:spPr>
-        <p:txBody>
-          <a:bodyPr wrap="square" lIns="0" tIns="0" rIns="0" bIns="0" rtlCol="0" anchor="t"/>
-          <a:lstStyle/>
-          <a:p>
-            <a:pPr indent="0" marL="0">
-              <a:buNone/>
-            </a:pPr>
-            <a:r>
-              <a:rPr lang="en-US" sz="1100" dirty="0">
-                <a:solidFill>
-                  <a:schemeClr val="tx2"/>
-                </a:solidFill>
-              </a:rPr>
-              <a:t>Example figures, not a forecast. We recalculate with your clinic's numbers during onboarding.</a:t>
-            </a:r>
-            <a:endParaRPr lang="en-US" sz="1100" dirty="0"/>
           </a:p>
         </p:txBody>
       </p:sp>
@@ -8735,8 +8833,8 @@
         </p:blipFill>
         <p:spPr>
           <a:xfrm>
-            <a:off x="731520" y="3172968"/>
-            <a:ext cx="384048" cy="384048"/>
+            <a:off x="731520" y="2944368"/>
+            <a:ext cx="329184" cy="329184"/>
           </a:xfrm>
           <a:prstGeom prst="rect">
             <a:avLst/>
@@ -8751,8 +8849,8 @@
         </p:nvSpPr>
         <p:spPr>
           <a:xfrm>
-            <a:off x="1325880" y="3154680"/>
-            <a:ext cx="4572000" cy="822960"/>
+            <a:off x="1234440" y="2926080"/>
+            <a:ext cx="4754880" cy="731520"/>
           </a:xfrm>
           <a:prstGeom prst="rect">
             <a:avLst/>
@@ -8768,14 +8866,25 @@
               <a:buNone/>
             </a:pPr>
             <a:r>
-              <a:rPr lang="en-US" sz="2000" dirty="0">
+              <a:rPr lang="en-US" sz="1700" b="1" dirty="0">
+                <a:solidFill>
+                  <a:schemeClr val="accent2"/>
+                </a:solidFill>
+              </a:rPr>
+              <a:t>More revenue: </a:t>
+            </a:r>
+            <a:pPr indent="0" marL="0">
+              <a:buNone/>
+            </a:pPr>
+            <a:r>
+              <a:rPr lang="en-US" sz="1700" dirty="0">
                 <a:solidFill>
                   <a:schemeClr val="bg1"/>
                 </a:solidFill>
               </a:rPr>
-              <a:t>More consistent patient follow-ups.</a:t>
-            </a:r>
-            <a:endParaRPr lang="en-US" sz="2000" dirty="0"/>
+              <a:t>more enquiries turn into appointments.</a:t>
+            </a:r>
+            <a:endParaRPr lang="en-US" sz="1700" dirty="0"/>
           </a:p>
         </p:txBody>
       </p:sp>
@@ -8795,8 +8904,8 @@
         </p:blipFill>
         <p:spPr>
           <a:xfrm>
-            <a:off x="6217920" y="3172968"/>
-            <a:ext cx="384048" cy="384048"/>
+            <a:off x="6217920" y="2944368"/>
+            <a:ext cx="329184" cy="329184"/>
           </a:xfrm>
           <a:prstGeom prst="rect">
             <a:avLst/>
@@ -8811,8 +8920,8 @@
         </p:nvSpPr>
         <p:spPr>
           <a:xfrm>
-            <a:off x="6812280" y="3154680"/>
-            <a:ext cx="4572000" cy="822960"/>
+            <a:off x="6720840" y="2926080"/>
+            <a:ext cx="4754880" cy="731520"/>
           </a:xfrm>
           <a:prstGeom prst="rect">
             <a:avLst/>
@@ -8828,14 +8937,25 @@
               <a:buNone/>
             </a:pPr>
             <a:r>
-              <a:rPr lang="en-US" sz="2000" dirty="0">
+              <a:rPr lang="en-US" sz="1700" b="1" dirty="0">
+                <a:solidFill>
+                  <a:schemeClr val="accent2"/>
+                </a:solidFill>
+              </a:rPr>
+              <a:t>More reviews: </a:t>
+            </a:r>
+            <a:pPr indent="0" marL="0">
+              <a:buNone/>
+            </a:pPr>
+            <a:r>
+              <a:rPr lang="en-US" sz="1700" dirty="0">
                 <a:solidFill>
                   <a:schemeClr val="bg1"/>
                 </a:solidFill>
               </a:rPr>
-              <a:t>Fewer missed booking opportunities.</a:t>
-            </a:r>
-            <a:endParaRPr lang="en-US" sz="2000" dirty="0"/>
+              <a:t>positive reviews land on Google; negative feedback lands in your inbox.</a:t>
+            </a:r>
+            <a:endParaRPr lang="en-US" sz="1700" dirty="0"/>
           </a:p>
         </p:txBody>
       </p:sp>
@@ -8855,8 +8975,8 @@
         </p:blipFill>
         <p:spPr>
           <a:xfrm>
-            <a:off x="731520" y="4178808"/>
-            <a:ext cx="384048" cy="384048"/>
+            <a:off x="731520" y="3749040"/>
+            <a:ext cx="329184" cy="329184"/>
           </a:xfrm>
           <a:prstGeom prst="rect">
             <a:avLst/>
@@ -8871,8 +8991,8 @@
         </p:nvSpPr>
         <p:spPr>
           <a:xfrm>
-            <a:off x="1325880" y="4160520"/>
-            <a:ext cx="4572000" cy="822960"/>
+            <a:off x="1234440" y="3730752"/>
+            <a:ext cx="4754880" cy="731520"/>
           </a:xfrm>
           <a:prstGeom prst="rect">
             <a:avLst/>
@@ -8887,15 +9007,18 @@
             <a:pPr indent="0" marL="0">
               <a:buNone/>
             </a:pPr>
-            <a:r>
-              <a:rPr lang="en-US" sz="2000" dirty="0">
+            <a:pPr indent="0" marL="0">
+              <a:buNone/>
+            </a:pPr>
+            <a:r>
+              <a:rPr lang="en-US" sz="1700" dirty="0">
                 <a:solidFill>
                   <a:schemeClr val="bg1"/>
                 </a:solidFill>
               </a:rPr>
-              <a:t>Better reactivation of inactive patients.</a:t>
-            </a:r>
-            <a:endParaRPr lang="en-US" sz="2000" dirty="0"/>
+              <a:t>More consistent patient follow-ups.</a:t>
+            </a:r>
+            <a:endParaRPr lang="en-US" sz="1700" dirty="0"/>
           </a:p>
         </p:txBody>
       </p:sp>
@@ -8915,8 +9038,8 @@
         </p:blipFill>
         <p:spPr>
           <a:xfrm>
-            <a:off x="6217920" y="4178808"/>
-            <a:ext cx="384048" cy="384048"/>
+            <a:off x="6217920" y="3749040"/>
+            <a:ext cx="329184" cy="329184"/>
           </a:xfrm>
           <a:prstGeom prst="rect">
             <a:avLst/>
@@ -8931,8 +9054,8 @@
         </p:nvSpPr>
         <p:spPr>
           <a:xfrm>
-            <a:off x="6812280" y="4160520"/>
-            <a:ext cx="4572000" cy="822960"/>
+            <a:off x="6720840" y="3730752"/>
+            <a:ext cx="4754880" cy="731520"/>
           </a:xfrm>
           <a:prstGeom prst="rect">
             <a:avLst/>
@@ -8947,21 +9070,150 @@
             <a:pPr indent="0" marL="0">
               <a:buNone/>
             </a:pPr>
-            <a:r>
-              <a:rPr lang="en-US" sz="2000" dirty="0">
+            <a:pPr indent="0" marL="0">
+              <a:buNone/>
+            </a:pPr>
+            <a:r>
+              <a:rPr lang="en-US" sz="1700" dirty="0">
                 <a:solidFill>
                   <a:schemeClr val="bg1"/>
                 </a:solidFill>
               </a:rPr>
+              <a:t>Fewer missed booking opportunities.</a:t>
+            </a:r>
+            <a:endParaRPr lang="en-US" sz="1700" dirty="0"/>
+          </a:p>
+        </p:txBody>
+      </p:sp>
+      <p:pic>
+        <p:nvPicPr>
+          <p:cNvPr id="11" name="Image 4" descr="preencoded.png">    </p:cNvPr>
+          <p:cNvPicPr>
+            <a:picLocks noChangeAspect="1"/>
+          </p:cNvPicPr>
+          <p:nvPr/>
+        </p:nvPicPr>
+        <p:blipFill>
+          <a:blip r:embed="rId5"/>
+          <a:stretch>
+            <a:fillRect/>
+          </a:stretch>
+        </p:blipFill>
+        <p:spPr>
+          <a:xfrm>
+            <a:off x="731520" y="4553712"/>
+            <a:ext cx="329184" cy="329184"/>
+          </a:xfrm>
+          <a:prstGeom prst="rect">
+            <a:avLst/>
+          </a:prstGeom>
+        </p:spPr>
+      </p:pic>
+      <p:sp>
+        <p:nvSpPr>
+          <p:cNvPr id="12" name="Text 5"/>
+          <p:cNvSpPr txBox="1"/>
+          <p:nvPr/>
+        </p:nvSpPr>
+        <p:spPr>
+          <a:xfrm>
+            <a:off x="1234440" y="4535424"/>
+            <a:ext cx="4754880" cy="731520"/>
+          </a:xfrm>
+          <a:prstGeom prst="rect">
+            <a:avLst/>
+          </a:prstGeom>
+          <a:noFill/>
+          <a:ln/>
+        </p:spPr>
+        <p:txBody>
+          <a:bodyPr wrap="square" lIns="0" tIns="0" rIns="0" bIns="0" rtlCol="0" anchor="t"/>
+          <a:lstStyle/>
+          <a:p>
+            <a:pPr indent="0" marL="0">
+              <a:buNone/>
+            </a:pPr>
+            <a:pPr indent="0" marL="0">
+              <a:buNone/>
+            </a:pPr>
+            <a:r>
+              <a:rPr lang="en-US" sz="1700" dirty="0">
+                <a:solidFill>
+                  <a:schemeClr val="bg1"/>
+                </a:solidFill>
+              </a:rPr>
+              <a:t>Better reactivation of inactive patients.</a:t>
+            </a:r>
+            <a:endParaRPr lang="en-US" sz="1700" dirty="0"/>
+          </a:p>
+        </p:txBody>
+      </p:sp>
+      <p:pic>
+        <p:nvPicPr>
+          <p:cNvPr id="13" name="Image 5" descr="preencoded.png">    </p:cNvPr>
+          <p:cNvPicPr>
+            <a:picLocks noChangeAspect="1"/>
+          </p:cNvPicPr>
+          <p:nvPr/>
+        </p:nvPicPr>
+        <p:blipFill>
+          <a:blip r:embed="rId6"/>
+          <a:stretch>
+            <a:fillRect/>
+          </a:stretch>
+        </p:blipFill>
+        <p:spPr>
+          <a:xfrm>
+            <a:off x="6217920" y="4553712"/>
+            <a:ext cx="329184" cy="329184"/>
+          </a:xfrm>
+          <a:prstGeom prst="rect">
+            <a:avLst/>
+          </a:prstGeom>
+        </p:spPr>
+      </p:pic>
+      <p:sp>
+        <p:nvSpPr>
+          <p:cNvPr id="14" name="Text 6"/>
+          <p:cNvSpPr txBox="1"/>
+          <p:nvPr/>
+        </p:nvSpPr>
+        <p:spPr>
+          <a:xfrm>
+            <a:off x="6720840" y="4535424"/>
+            <a:ext cx="4754880" cy="731520"/>
+          </a:xfrm>
+          <a:prstGeom prst="rect">
+            <a:avLst/>
+          </a:prstGeom>
+          <a:noFill/>
+          <a:ln/>
+        </p:spPr>
+        <p:txBody>
+          <a:bodyPr wrap="square" lIns="0" tIns="0" rIns="0" bIns="0" rtlCol="0" anchor="t"/>
+          <a:lstStyle/>
+          <a:p>
+            <a:pPr indent="0" marL="0">
+              <a:buNone/>
+            </a:pPr>
+            <a:pPr indent="0" marL="0">
+              <a:buNone/>
+            </a:pPr>
+            <a:r>
+              <a:rPr lang="en-US" sz="1700" dirty="0">
+                <a:solidFill>
+                  <a:schemeClr val="bg1"/>
+                </a:solidFill>
+              </a:rPr>
               <a:t>Improved visibility into enquiry and appointment outcomes.</a:t>
             </a:r>
-            <a:endParaRPr lang="en-US" sz="2000" dirty="0"/>
-          </a:p>
-        </p:txBody>
-      </p:sp>
-      <p:sp>
-        <p:nvSpPr>
-          <p:cNvPr id="11" name="Text 5"/>
+            <a:endParaRPr lang="en-US" sz="1700" dirty="0"/>
+          </a:p>
+        </p:txBody>
+      </p:sp>
+      <p:sp>
+        <p:nvSpPr>
+          <p:cNvPr id="15" name="Text 7"/>
           <p:cNvSpPr txBox="1"/>
           <p:nvPr/>
         </p:nvSpPr>

</xml_diff>

<commit_message>
Add review workflow to patient journey slide
Co-Authored-By: Claude Opus 5.5 <noreply@anthropic.com>
Claude-Session: https://claude.ai/code/session_016ZGbiuM9ffruZKrFMKYq5D
</commit_message>
<xml_diff>
--- a/Patientcurve-Proposal-Dr-Mohanapriya.pptx
+++ b/Patientcurve-Proposal-Dr-Mohanapriya.pptx
@@ -114,30 +114,30 @@
   <p:extLst>
     <p:ext uri="{521415D9-36F7-43E2-AB2F-B90AF26B5E84}">
       <p14:sectionLst xmlns:p14="http://schemas.microsoft.com/office/powerpoint/2010/main">
-        <p14:section name="Introduction" id="{07964782-521c-9233-8560-5dfa54f73950}">
+        <p14:section name="Introduction" id="{a3663388-2a2e-7c52-6e98-1522b8d6ed61}">
           <p14:sldIdLst>
             <p14:sldId id="256"/>
           </p14:sldIdLst>
         </p14:section>
-        <p14:section name="The opportunity" id="{daa59b9b-d290-98c8-90ea-8e79b2285339}">
+        <p14:section name="The opportunity" id="{05c7b7f5-c2e4-2506-09b2-411a18096757}">
           <p14:sldIdLst>
             <p14:sldId id="257"/>
           </p14:sldIdLst>
         </p14:section>
-        <p14:section name="The solution" id="{ac8f45e7-3f41-cbea-58ad-04cf2ada8976}">
+        <p14:section name="The solution" id="{d477de28-a426-97e2-357d-4de0930143c2}">
           <p14:sldIdLst>
             <p14:sldId id="258"/>
             <p14:sldId id="259"/>
           </p14:sldIdLst>
         </p14:section>
-        <p14:section name="Investment" id="{7bd56e07-a59c-8db6-0d40-8a1b554ea82b}">
+        <p14:section name="Investment" id="{d4f04f5b-8984-3277-715a-6e4c6f9679e4}">
           <p14:sldIdLst>
             <p14:sldId id="260"/>
             <p14:sldId id="261"/>
             <p14:sldId id="262"/>
           </p14:sldIdLst>
         </p14:section>
-        <p14:section name="The decision" id="{9ffcba34-d3ac-ceba-96eb-0251c232f5be}">
+        <p14:section name="The decision" id="{9875e509-3cdc-f43f-1fbe-ac72727b6939}">
           <p14:sldIdLst>
             <p14:sldId id="263"/>
           </p14:sldIdLst>
@@ -722,7 +722,7 @@
           <a:p>
             <a:r>
               <a:rPr lang="en-US" dirty="0"/>
-              <a:t>Walk the path: ad, WhatsApp enquiry, details, location and need, then an approved answer. Local patients are offered offline consultation, other towns video. Booked patients land in Google Calendar. Anyone who doesn't book goes on the call list; the receptionist calls, brings the patient back or closes them, and updates the PMS.</a:t>
+              <a:t>Walk the path: ad, WhatsApp enquiry, details, location and need, then an approved answer. Local patients are offered offline consultation, other towns video. Booked patients land in Google Calendar. After the visit, your receptionist marks it done and the patient gets a review request: 4 or 5 stars are invited to post on Google, 1 to 3 stars stay private and come to your inbox. Anyone who doesn't book goes on the call list; the receptionist calls, brings the patient back or closes them, and updates the PMS.</a:t>
             </a:r>
             <a:endParaRPr lang="en-US" dirty="0"/>
           </a:p>
@@ -4501,9 +4501,9 @@
           <p:nvPr/>
         </p:nvSpPr>
         <p:spPr>
-          <a:xfrm flipH="1">
-            <a:off x="2926080" y="3337560"/>
-            <a:ext cx="1097280" cy="0"/>
+          <a:xfrm>
+            <a:off x="1737360" y="3680460"/>
+            <a:ext cx="0" cy="297180"/>
           </a:xfrm>
           <a:prstGeom prst="line">
             <a:avLst/>
@@ -4526,12 +4526,12 @@
         </p:nvSpPr>
         <p:spPr>
           <a:xfrm>
-            <a:off x="4023360" y="4983480"/>
-            <a:ext cx="1920240" cy="685800"/>
+            <a:off x="548640" y="3977640"/>
+            <a:ext cx="2377440" cy="566928"/>
           </a:xfrm>
           <a:prstGeom prst="roundRect">
             <a:avLst>
-              <a:gd name="adj" fmla="val 13333"/>
+              <a:gd name="adj" fmla="val 16129"/>
             </a:avLst>
           </a:prstGeom>
           <a:solidFill>
@@ -4553,8 +4553,8 @@
         </p:nvSpPr>
         <p:spPr>
           <a:xfrm>
-            <a:off x="4023360" y="4983480"/>
-            <a:ext cx="1920240" cy="685800"/>
+            <a:off x="548640" y="3977640"/>
+            <a:ext cx="2377440" cy="566928"/>
           </a:xfrm>
           <a:prstGeom prst="rect">
             <a:avLst/>
@@ -4575,7 +4575,21 @@
                   <a:schemeClr val="tx1"/>
                 </a:solidFill>
               </a:rPr>
-              <a:t>Call list</a:t>
+              <a:t>Visit done</a:t>
+            </a:r>
+            <a:endParaRPr lang="en-US" sz="1400" dirty="0"/>
+          </a:p>
+          <a:p>
+            <a:pPr algn="ctr" indent="0" marL="0">
+              <a:buNone/>
+            </a:pPr>
+            <a:r>
+              <a:rPr lang="en-US" sz="1100" dirty="0">
+                <a:solidFill>
+                  <a:schemeClr val="tx2"/>
+                </a:solidFill>
+              </a:rPr>
+              <a:t>marked by your receptionist</a:t>
             </a:r>
             <a:endParaRPr lang="en-US" sz="1400" dirty="0"/>
           </a:p>
@@ -4589,12 +4603,36 @@
         </p:nvSpPr>
         <p:spPr>
           <a:xfrm>
-            <a:off x="6583680" y="4983480"/>
-            <a:ext cx="1920240" cy="685800"/>
+            <a:off x="1737360" y="4544568"/>
+            <a:ext cx="0" cy="274320"/>
+          </a:xfrm>
+          <a:prstGeom prst="line">
+            <a:avLst/>
+          </a:prstGeom>
+          <a:noFill/>
+          <a:ln w="15875">
+            <a:solidFill>
+              <a:schemeClr val="tx2"/>
+            </a:solidFill>
+            <a:prstDash val="solid"/>
+            <a:tailEnd type="triangle"/>
+          </a:ln>
+        </p:spPr>
+      </p:sp>
+      <p:sp>
+        <p:nvSpPr>
+          <p:cNvPr id="41" name="Shape 39"/>
+          <p:cNvSpPr/>
+          <p:nvPr/>
+        </p:nvSpPr>
+        <p:spPr>
+          <a:xfrm>
+            <a:off x="548640" y="4818888"/>
+            <a:ext cx="2377440" cy="566928"/>
           </a:xfrm>
           <a:prstGeom prst="roundRect">
             <a:avLst>
-              <a:gd name="adj" fmla="val 13333"/>
+              <a:gd name="adj" fmla="val 16129"/>
             </a:avLst>
           </a:prstGeom>
           <a:solidFill>
@@ -4610,14 +4648,14 @@
       </p:sp>
       <p:sp>
         <p:nvSpPr>
-          <p:cNvPr id="41" name="Text 39"/>
+          <p:cNvPr id="42" name="Text 40"/>
           <p:cNvSpPr txBox="1"/>
           <p:nvPr/>
         </p:nvSpPr>
         <p:spPr>
           <a:xfrm>
-            <a:off x="6583680" y="4983480"/>
-            <a:ext cx="1920240" cy="685800"/>
+            <a:off x="548640" y="4818888"/>
+            <a:ext cx="2377440" cy="566928"/>
           </a:xfrm>
           <a:prstGeom prst="rect">
             <a:avLst/>
@@ -4638,26 +4676,206 @@
                   <a:schemeClr val="tx1"/>
                 </a:solidFill>
               </a:rPr>
-              <a:t>Receptionist calls</a:t>
+              <a:t>Review request</a:t>
             </a:r>
             <a:endParaRPr lang="en-US" sz="1400" dirty="0"/>
           </a:p>
-        </p:txBody>
-      </p:sp>
-      <p:sp>
-        <p:nvSpPr>
-          <p:cNvPr id="42" name="Shape 40"/>
+          <a:p>
+            <a:pPr algn="ctr" indent="0" marL="0">
+              <a:buNone/>
+            </a:pPr>
+            <a:r>
+              <a:rPr lang="en-US" sz="1100" dirty="0">
+                <a:solidFill>
+                  <a:schemeClr val="tx2"/>
+                </a:solidFill>
+              </a:rPr>
+              <a:t>sent after the visit</a:t>
+            </a:r>
+            <a:endParaRPr lang="en-US" sz="1400" dirty="0"/>
+          </a:p>
+        </p:txBody>
+      </p:sp>
+      <p:sp>
+        <p:nvSpPr>
+          <p:cNvPr id="43" name="Shape 41"/>
           <p:cNvSpPr/>
           <p:nvPr/>
         </p:nvSpPr>
         <p:spPr>
           <a:xfrm>
-            <a:off x="9144000" y="4983480"/>
-            <a:ext cx="1920240" cy="685800"/>
+            <a:off x="1737360" y="5385816"/>
+            <a:ext cx="0" cy="82296"/>
+          </a:xfrm>
+          <a:prstGeom prst="line">
+            <a:avLst/>
+          </a:prstGeom>
+          <a:noFill/>
+          <a:ln w="15875">
+            <a:solidFill>
+              <a:schemeClr val="tx2"/>
+            </a:solidFill>
+            <a:prstDash val="solid"/>
+          </a:ln>
+        </p:spPr>
+      </p:sp>
+      <p:sp>
+        <p:nvSpPr>
+          <p:cNvPr id="44" name="Shape 42"/>
+          <p:cNvSpPr/>
+          <p:nvPr/>
+        </p:nvSpPr>
+        <p:spPr>
+          <a:xfrm>
+            <a:off x="1120140" y="5468112"/>
+            <a:ext cx="1234440" cy="0"/>
+          </a:xfrm>
+          <a:prstGeom prst="line">
+            <a:avLst/>
+          </a:prstGeom>
+          <a:noFill/>
+          <a:ln w="15875">
+            <a:solidFill>
+              <a:schemeClr val="tx2"/>
+            </a:solidFill>
+            <a:prstDash val="solid"/>
+          </a:ln>
+        </p:spPr>
+      </p:sp>
+      <p:sp>
+        <p:nvSpPr>
+          <p:cNvPr id="45" name="Shape 43"/>
+          <p:cNvSpPr/>
+          <p:nvPr/>
+        </p:nvSpPr>
+        <p:spPr>
+          <a:xfrm>
+            <a:off x="1120140" y="5468112"/>
+            <a:ext cx="0" cy="128016"/>
+          </a:xfrm>
+          <a:prstGeom prst="line">
+            <a:avLst/>
+          </a:prstGeom>
+          <a:noFill/>
+          <a:ln w="15875">
+            <a:solidFill>
+              <a:schemeClr val="tx2"/>
+            </a:solidFill>
+            <a:prstDash val="solid"/>
+            <a:tailEnd type="triangle"/>
+          </a:ln>
+        </p:spPr>
+      </p:sp>
+      <p:sp>
+        <p:nvSpPr>
+          <p:cNvPr id="46" name="Shape 44"/>
+          <p:cNvSpPr/>
+          <p:nvPr/>
+        </p:nvSpPr>
+        <p:spPr>
+          <a:xfrm>
+            <a:off x="2354580" y="5468112"/>
+            <a:ext cx="0" cy="128016"/>
+          </a:xfrm>
+          <a:prstGeom prst="line">
+            <a:avLst/>
+          </a:prstGeom>
+          <a:noFill/>
+          <a:ln w="15875">
+            <a:solidFill>
+              <a:schemeClr val="tx2"/>
+            </a:solidFill>
+            <a:prstDash val="solid"/>
+            <a:tailEnd type="triangle"/>
+          </a:ln>
+        </p:spPr>
+      </p:sp>
+      <p:sp>
+        <p:nvSpPr>
+          <p:cNvPr id="47" name="Shape 45"/>
+          <p:cNvSpPr/>
+          <p:nvPr/>
+        </p:nvSpPr>
+        <p:spPr>
+          <a:xfrm>
+            <a:off x="548640" y="5596128"/>
+            <a:ext cx="1143000" cy="512064"/>
           </a:xfrm>
           <a:prstGeom prst="roundRect">
             <a:avLst>
-              <a:gd name="adj" fmla="val 13333"/>
+              <a:gd name="adj" fmla="val 14286"/>
+            </a:avLst>
+          </a:prstGeom>
+          <a:solidFill>
+            <a:schemeClr val="accent1"/>
+          </a:solidFill>
+          <a:ln/>
+        </p:spPr>
+      </p:sp>
+      <p:sp>
+        <p:nvSpPr>
+          <p:cNvPr id="48" name="Text 46"/>
+          <p:cNvSpPr txBox="1"/>
+          <p:nvPr/>
+        </p:nvSpPr>
+        <p:spPr>
+          <a:xfrm>
+            <a:off x="548640" y="5596128"/>
+            <a:ext cx="1143000" cy="512064"/>
+          </a:xfrm>
+          <a:prstGeom prst="rect">
+            <a:avLst/>
+          </a:prstGeom>
+          <a:noFill/>
+          <a:ln/>
+        </p:spPr>
+        <p:txBody>
+          <a:bodyPr wrap="square" lIns="381" tIns="381" rIns="381" bIns="381" rtlCol="0" anchor="ctr"/>
+          <a:lstStyle/>
+          <a:p>
+            <a:pPr algn="ctr" indent="0" marL="0">
+              <a:buNone/>
+            </a:pPr>
+            <a:r>
+              <a:rPr lang="en-US" sz="1200" b="1" dirty="0">
+                <a:solidFill>
+                  <a:schemeClr val="bg1"/>
+                </a:solidFill>
+              </a:rPr>
+              <a:t>Google review</a:t>
+            </a:r>
+            <a:endParaRPr lang="en-US" sz="1200" dirty="0"/>
+          </a:p>
+          <a:p>
+            <a:pPr algn="ctr" indent="0" marL="0">
+              <a:buNone/>
+            </a:pPr>
+            <a:r>
+              <a:rPr lang="en-US" sz="1000" dirty="0">
+                <a:solidFill>
+                  <a:schemeClr val="bg1"/>
+                </a:solidFill>
+              </a:rPr>
+              <a:t>4–5 stars</a:t>
+            </a:r>
+            <a:endParaRPr lang="en-US" sz="1200" dirty="0"/>
+          </a:p>
+        </p:txBody>
+      </p:sp>
+      <p:sp>
+        <p:nvSpPr>
+          <p:cNvPr id="49" name="Shape 47"/>
+          <p:cNvSpPr/>
+          <p:nvPr/>
+        </p:nvSpPr>
+        <p:spPr>
+          <a:xfrm>
+            <a:off x="1783080" y="5596128"/>
+            <a:ext cx="1143000" cy="512064"/>
+          </a:xfrm>
+          <a:prstGeom prst="roundRect">
+            <a:avLst>
+              <a:gd name="adj" fmla="val 14286"/>
             </a:avLst>
           </a:prstGeom>
           <a:solidFill>
@@ -4673,50 +4891,64 @@
       </p:sp>
       <p:sp>
         <p:nvSpPr>
-          <p:cNvPr id="43" name="Text 41"/>
+          <p:cNvPr id="50" name="Text 48"/>
           <p:cNvSpPr txBox="1"/>
           <p:nvPr/>
         </p:nvSpPr>
         <p:spPr>
           <a:xfrm>
-            <a:off x="9144000" y="4983480"/>
-            <a:ext cx="1920240" cy="685800"/>
-          </a:xfrm>
-          <a:prstGeom prst="rect">
-            <a:avLst/>
-          </a:prstGeom>
-          <a:noFill/>
-          <a:ln/>
-        </p:spPr>
-        <p:txBody>
-          <a:bodyPr wrap="square" lIns="635" tIns="635" rIns="635" bIns="635" rtlCol="0" anchor="ctr"/>
+            <a:off x="1783080" y="5596128"/>
+            <a:ext cx="1143000" cy="512064"/>
+          </a:xfrm>
+          <a:prstGeom prst="rect">
+            <a:avLst/>
+          </a:prstGeom>
+          <a:noFill/>
+          <a:ln/>
+        </p:spPr>
+        <p:txBody>
+          <a:bodyPr wrap="square" lIns="381" tIns="381" rIns="381" bIns="381" rtlCol="0" anchor="ctr"/>
           <a:lstStyle/>
           <a:p>
             <a:pPr algn="ctr" indent="0" marL="0">
               <a:buNone/>
             </a:pPr>
             <a:r>
-              <a:rPr lang="en-US" sz="1400" b="1" dirty="0">
+              <a:rPr lang="en-US" sz="1200" b="1" dirty="0">
                 <a:solidFill>
                   <a:schemeClr val="tx1"/>
                 </a:solidFill>
               </a:rPr>
-              <a:t>Update PMS</a:t>
-            </a:r>
-            <a:endParaRPr lang="en-US" sz="1400" dirty="0"/>
-          </a:p>
-        </p:txBody>
-      </p:sp>
-      <p:sp>
-        <p:nvSpPr>
-          <p:cNvPr id="44" name="Shape 42"/>
+              <a:t>Your inbox</a:t>
+            </a:r>
+            <a:endParaRPr lang="en-US" sz="1200" dirty="0"/>
+          </a:p>
+          <a:p>
+            <a:pPr algn="ctr" indent="0" marL="0">
+              <a:buNone/>
+            </a:pPr>
+            <a:r>
+              <a:rPr lang="en-US" sz="1000" dirty="0">
+                <a:solidFill>
+                  <a:schemeClr val="tx2"/>
+                </a:solidFill>
+              </a:rPr>
+              <a:t>1–3 stars, private</a:t>
+            </a:r>
+            <a:endParaRPr lang="en-US" sz="1200" dirty="0"/>
+          </a:p>
+        </p:txBody>
+      </p:sp>
+      <p:sp>
+        <p:nvSpPr>
+          <p:cNvPr id="51" name="Shape 49"/>
           <p:cNvSpPr/>
           <p:nvPr/>
         </p:nvSpPr>
         <p:spPr>
-          <a:xfrm>
-            <a:off x="5943600" y="5326380"/>
-            <a:ext cx="640080" cy="0"/>
+          <a:xfrm flipH="1">
+            <a:off x="2926080" y="3337560"/>
+            <a:ext cx="1097280" cy="0"/>
           </a:xfrm>
           <a:prstGeom prst="line">
             <a:avLst/>
@@ -4733,13 +4965,202 @@
       </p:sp>
       <p:sp>
         <p:nvSpPr>
-          <p:cNvPr id="45" name="Shape 43"/>
+          <p:cNvPr id="52" name="Shape 50"/>
           <p:cNvSpPr/>
           <p:nvPr/>
         </p:nvSpPr>
         <p:spPr>
           <a:xfrm>
-            <a:off x="8503920" y="5326380"/>
+            <a:off x="4023360" y="4983480"/>
+            <a:ext cx="1920240" cy="685800"/>
+          </a:xfrm>
+          <a:prstGeom prst="roundRect">
+            <a:avLst>
+              <a:gd name="adj" fmla="val 13333"/>
+            </a:avLst>
+          </a:prstGeom>
+          <a:solidFill>
+            <a:schemeClr val="bg1"/>
+          </a:solidFill>
+          <a:ln w="9525">
+            <a:solidFill>
+              <a:srgbClr val="D5DEDB"/>
+            </a:solidFill>
+            <a:prstDash val="solid"/>
+          </a:ln>
+        </p:spPr>
+      </p:sp>
+      <p:sp>
+        <p:nvSpPr>
+          <p:cNvPr id="53" name="Text 51"/>
+          <p:cNvSpPr txBox="1"/>
+          <p:nvPr/>
+        </p:nvSpPr>
+        <p:spPr>
+          <a:xfrm>
+            <a:off x="4023360" y="4983480"/>
+            <a:ext cx="1920240" cy="685800"/>
+          </a:xfrm>
+          <a:prstGeom prst="rect">
+            <a:avLst/>
+          </a:prstGeom>
+          <a:noFill/>
+          <a:ln/>
+        </p:spPr>
+        <p:txBody>
+          <a:bodyPr wrap="square" lIns="635" tIns="635" rIns="635" bIns="635" rtlCol="0" anchor="ctr"/>
+          <a:lstStyle/>
+          <a:p>
+            <a:pPr algn="ctr" indent="0" marL="0">
+              <a:buNone/>
+            </a:pPr>
+            <a:r>
+              <a:rPr lang="en-US" sz="1400" b="1" dirty="0">
+                <a:solidFill>
+                  <a:schemeClr val="tx1"/>
+                </a:solidFill>
+              </a:rPr>
+              <a:t>Call list</a:t>
+            </a:r>
+            <a:endParaRPr lang="en-US" sz="1400" dirty="0"/>
+          </a:p>
+        </p:txBody>
+      </p:sp>
+      <p:sp>
+        <p:nvSpPr>
+          <p:cNvPr id="54" name="Shape 52"/>
+          <p:cNvSpPr/>
+          <p:nvPr/>
+        </p:nvSpPr>
+        <p:spPr>
+          <a:xfrm>
+            <a:off x="6583680" y="4983480"/>
+            <a:ext cx="1920240" cy="685800"/>
+          </a:xfrm>
+          <a:prstGeom prst="roundRect">
+            <a:avLst>
+              <a:gd name="adj" fmla="val 13333"/>
+            </a:avLst>
+          </a:prstGeom>
+          <a:solidFill>
+            <a:schemeClr val="bg1"/>
+          </a:solidFill>
+          <a:ln w="9525">
+            <a:solidFill>
+              <a:srgbClr val="D5DEDB"/>
+            </a:solidFill>
+            <a:prstDash val="solid"/>
+          </a:ln>
+        </p:spPr>
+      </p:sp>
+      <p:sp>
+        <p:nvSpPr>
+          <p:cNvPr id="55" name="Text 53"/>
+          <p:cNvSpPr txBox="1"/>
+          <p:nvPr/>
+        </p:nvSpPr>
+        <p:spPr>
+          <a:xfrm>
+            <a:off x="6583680" y="4983480"/>
+            <a:ext cx="1920240" cy="685800"/>
+          </a:xfrm>
+          <a:prstGeom prst="rect">
+            <a:avLst/>
+          </a:prstGeom>
+          <a:noFill/>
+          <a:ln/>
+        </p:spPr>
+        <p:txBody>
+          <a:bodyPr wrap="square" lIns="635" tIns="635" rIns="635" bIns="635" rtlCol="0" anchor="ctr"/>
+          <a:lstStyle/>
+          <a:p>
+            <a:pPr algn="ctr" indent="0" marL="0">
+              <a:buNone/>
+            </a:pPr>
+            <a:r>
+              <a:rPr lang="en-US" sz="1400" b="1" dirty="0">
+                <a:solidFill>
+                  <a:schemeClr val="tx1"/>
+                </a:solidFill>
+              </a:rPr>
+              <a:t>Receptionist calls</a:t>
+            </a:r>
+            <a:endParaRPr lang="en-US" sz="1400" dirty="0"/>
+          </a:p>
+        </p:txBody>
+      </p:sp>
+      <p:sp>
+        <p:nvSpPr>
+          <p:cNvPr id="56" name="Shape 54"/>
+          <p:cNvSpPr/>
+          <p:nvPr/>
+        </p:nvSpPr>
+        <p:spPr>
+          <a:xfrm>
+            <a:off x="9144000" y="4983480"/>
+            <a:ext cx="1920240" cy="685800"/>
+          </a:xfrm>
+          <a:prstGeom prst="roundRect">
+            <a:avLst>
+              <a:gd name="adj" fmla="val 13333"/>
+            </a:avLst>
+          </a:prstGeom>
+          <a:solidFill>
+            <a:schemeClr val="bg1"/>
+          </a:solidFill>
+          <a:ln w="9525">
+            <a:solidFill>
+              <a:srgbClr val="D5DEDB"/>
+            </a:solidFill>
+            <a:prstDash val="solid"/>
+          </a:ln>
+        </p:spPr>
+      </p:sp>
+      <p:sp>
+        <p:nvSpPr>
+          <p:cNvPr id="57" name="Text 55"/>
+          <p:cNvSpPr txBox="1"/>
+          <p:nvPr/>
+        </p:nvSpPr>
+        <p:spPr>
+          <a:xfrm>
+            <a:off x="9144000" y="4983480"/>
+            <a:ext cx="1920240" cy="685800"/>
+          </a:xfrm>
+          <a:prstGeom prst="rect">
+            <a:avLst/>
+          </a:prstGeom>
+          <a:noFill/>
+          <a:ln/>
+        </p:spPr>
+        <p:txBody>
+          <a:bodyPr wrap="square" lIns="635" tIns="635" rIns="635" bIns="635" rtlCol="0" anchor="ctr"/>
+          <a:lstStyle/>
+          <a:p>
+            <a:pPr algn="ctr" indent="0" marL="0">
+              <a:buNone/>
+            </a:pPr>
+            <a:r>
+              <a:rPr lang="en-US" sz="1400" b="1" dirty="0">
+                <a:solidFill>
+                  <a:schemeClr val="tx1"/>
+                </a:solidFill>
+              </a:rPr>
+              <a:t>Update PMS</a:t>
+            </a:r>
+            <a:endParaRPr lang="en-US" sz="1400" dirty="0"/>
+          </a:p>
+        </p:txBody>
+      </p:sp>
+      <p:sp>
+        <p:nvSpPr>
+          <p:cNvPr id="58" name="Shape 56"/>
+          <p:cNvSpPr/>
+          <p:nvPr/>
+        </p:nvSpPr>
+        <p:spPr>
+          <a:xfrm>
+            <a:off x="5943600" y="5326380"/>
             <a:ext cx="640080" cy="0"/>
           </a:xfrm>
           <a:prstGeom prst="line">
@@ -4757,14 +5178,14 @@
       </p:sp>
       <p:sp>
         <p:nvSpPr>
-          <p:cNvPr id="46" name="Shape 44"/>
+          <p:cNvPr id="59" name="Shape 57"/>
           <p:cNvSpPr/>
           <p:nvPr/>
         </p:nvSpPr>
         <p:spPr>
           <a:xfrm>
-            <a:off x="4572000" y="3680460"/>
-            <a:ext cx="0" cy="1303020"/>
+            <a:off x="8503920" y="5326380"/>
+            <a:ext cx="640080" cy="0"/>
           </a:xfrm>
           <a:prstGeom prst="line">
             <a:avLst/>
@@ -4781,96 +5202,14 @@
       </p:sp>
       <p:sp>
         <p:nvSpPr>
-          <p:cNvPr id="47" name="Text 45"/>
-          <p:cNvSpPr txBox="1"/>
-          <p:nvPr/>
-        </p:nvSpPr>
-        <p:spPr>
-          <a:xfrm>
-            <a:off x="3200400" y="4206240"/>
-            <a:ext cx="1280160" cy="274320"/>
-          </a:xfrm>
-          <a:prstGeom prst="rect">
-            <a:avLst/>
-          </a:prstGeom>
-          <a:noFill/>
-          <a:ln/>
-        </p:spPr>
-        <p:txBody>
-          <a:bodyPr wrap="square" lIns="0" tIns="0" rIns="0" bIns="0" rtlCol="0" anchor="t"/>
-          <a:lstStyle/>
-          <a:p>
-            <a:pPr algn="r" indent="0" marL="0">
-              <a:buNone/>
-            </a:pPr>
-            <a:r>
-              <a:rPr lang="en-US" sz="1100" dirty="0">
-                <a:solidFill>
-                  <a:schemeClr val="tx2"/>
-                </a:solidFill>
-              </a:rPr>
-              <a:t>doesn't book</a:t>
-            </a:r>
-            <a:endParaRPr lang="en-US" sz="1100" dirty="0"/>
-          </a:p>
-        </p:txBody>
-      </p:sp>
-      <p:sp>
-        <p:nvSpPr>
-          <p:cNvPr id="48" name="Shape 46"/>
+          <p:cNvPr id="60" name="Shape 58"/>
           <p:cNvSpPr/>
           <p:nvPr/>
         </p:nvSpPr>
         <p:spPr>
-          <a:xfrm flipV="1">
-            <a:off x="7543800" y="4663440"/>
-            <a:ext cx="0" cy="320040"/>
-          </a:xfrm>
-          <a:prstGeom prst="line">
-            <a:avLst/>
-          </a:prstGeom>
-          <a:noFill/>
-          <a:ln w="15875">
-            <a:solidFill>
-              <a:schemeClr val="tx2"/>
-            </a:solidFill>
-            <a:prstDash val="solid"/>
-          </a:ln>
-        </p:spPr>
-      </p:sp>
-      <p:sp>
-        <p:nvSpPr>
-          <p:cNvPr id="49" name="Shape 47"/>
-          <p:cNvSpPr/>
-          <p:nvPr/>
-        </p:nvSpPr>
-        <p:spPr>
-          <a:xfrm flipH="1">
-            <a:off x="5486400" y="4663440"/>
-            <a:ext cx="2057400" cy="0"/>
-          </a:xfrm>
-          <a:prstGeom prst="line">
-            <a:avLst/>
-          </a:prstGeom>
-          <a:noFill/>
-          <a:ln w="15875">
-            <a:solidFill>
-              <a:schemeClr val="tx2"/>
-            </a:solidFill>
-            <a:prstDash val="solid"/>
-          </a:ln>
-        </p:spPr>
-      </p:sp>
-      <p:sp>
-        <p:nvSpPr>
-          <p:cNvPr id="50" name="Shape 48"/>
-          <p:cNvSpPr/>
-          <p:nvPr/>
-        </p:nvSpPr>
-        <p:spPr>
-          <a:xfrm flipV="1">
-            <a:off x="5486400" y="3680460"/>
-            <a:ext cx="0" cy="982980"/>
+          <a:xfrm>
+            <a:off x="4572000" y="3680460"/>
+            <a:ext cx="0" cy="1303020"/>
           </a:xfrm>
           <a:prstGeom prst="line">
             <a:avLst/>
@@ -4887,7 +5226,113 @@
       </p:sp>
       <p:sp>
         <p:nvSpPr>
-          <p:cNvPr id="51" name="Text 49"/>
+          <p:cNvPr id="61" name="Text 59"/>
+          <p:cNvSpPr txBox="1"/>
+          <p:nvPr/>
+        </p:nvSpPr>
+        <p:spPr>
+          <a:xfrm>
+            <a:off x="3200400" y="4206240"/>
+            <a:ext cx="1280160" cy="274320"/>
+          </a:xfrm>
+          <a:prstGeom prst="rect">
+            <a:avLst/>
+          </a:prstGeom>
+          <a:noFill/>
+          <a:ln/>
+        </p:spPr>
+        <p:txBody>
+          <a:bodyPr wrap="square" lIns="0" tIns="0" rIns="0" bIns="0" rtlCol="0" anchor="t"/>
+          <a:lstStyle/>
+          <a:p>
+            <a:pPr algn="r" indent="0" marL="0">
+              <a:buNone/>
+            </a:pPr>
+            <a:r>
+              <a:rPr lang="en-US" sz="1100" dirty="0">
+                <a:solidFill>
+                  <a:schemeClr val="tx2"/>
+                </a:solidFill>
+              </a:rPr>
+              <a:t>doesn't book</a:t>
+            </a:r>
+            <a:endParaRPr lang="en-US" sz="1100" dirty="0"/>
+          </a:p>
+        </p:txBody>
+      </p:sp>
+      <p:sp>
+        <p:nvSpPr>
+          <p:cNvPr id="62" name="Shape 60"/>
+          <p:cNvSpPr/>
+          <p:nvPr/>
+        </p:nvSpPr>
+        <p:spPr>
+          <a:xfrm flipV="1">
+            <a:off x="7543800" y="4663440"/>
+            <a:ext cx="0" cy="320040"/>
+          </a:xfrm>
+          <a:prstGeom prst="line">
+            <a:avLst/>
+          </a:prstGeom>
+          <a:noFill/>
+          <a:ln w="15875">
+            <a:solidFill>
+              <a:schemeClr val="tx2"/>
+            </a:solidFill>
+            <a:prstDash val="solid"/>
+          </a:ln>
+        </p:spPr>
+      </p:sp>
+      <p:sp>
+        <p:nvSpPr>
+          <p:cNvPr id="63" name="Shape 61"/>
+          <p:cNvSpPr/>
+          <p:nvPr/>
+        </p:nvSpPr>
+        <p:spPr>
+          <a:xfrm flipH="1">
+            <a:off x="5486400" y="4663440"/>
+            <a:ext cx="2057400" cy="0"/>
+          </a:xfrm>
+          <a:prstGeom prst="line">
+            <a:avLst/>
+          </a:prstGeom>
+          <a:noFill/>
+          <a:ln w="15875">
+            <a:solidFill>
+              <a:schemeClr val="tx2"/>
+            </a:solidFill>
+            <a:prstDash val="solid"/>
+          </a:ln>
+        </p:spPr>
+      </p:sp>
+      <p:sp>
+        <p:nvSpPr>
+          <p:cNvPr id="64" name="Shape 62"/>
+          <p:cNvSpPr/>
+          <p:nvPr/>
+        </p:nvSpPr>
+        <p:spPr>
+          <a:xfrm flipV="1">
+            <a:off x="5486400" y="3680460"/>
+            <a:ext cx="0" cy="982980"/>
+          </a:xfrm>
+          <a:prstGeom prst="line">
+            <a:avLst/>
+          </a:prstGeom>
+          <a:noFill/>
+          <a:ln w="15875">
+            <a:solidFill>
+              <a:schemeClr val="tx2"/>
+            </a:solidFill>
+            <a:prstDash val="solid"/>
+            <a:tailEnd type="triangle"/>
+          </a:ln>
+        </p:spPr>
+      </p:sp>
+      <p:sp>
+        <p:nvSpPr>
+          <p:cNvPr id="65" name="Text 63"/>
           <p:cNvSpPr txBox="1"/>
           <p:nvPr/>
         </p:nvSpPr>

</xml_diff>

<commit_message>
Simplify business case into a visual chain; polish deck
Removes the illustrative notice, rebuilds the business case as
enquiries -> don't book -> brought back -> revenue, adds leak cards
on the opportunity slide and tidies spacing.

Co-Authored-By: Claude Opus 5.5 <noreply@anthropic.com>
Claude-Session: https://claude.ai/code/session_016ZGbiuM9ffruZKrFMKYq5D
</commit_message>
<xml_diff>
--- a/Patientcurve-Proposal-Dr-Mohanapriya.pptx
+++ b/Patientcurve-Proposal-Dr-Mohanapriya.pptx
@@ -114,30 +114,30 @@
   <p:extLst>
     <p:ext uri="{521415D9-36F7-43E2-AB2F-B90AF26B5E84}">
       <p14:sectionLst xmlns:p14="http://schemas.microsoft.com/office/powerpoint/2010/main">
-        <p14:section name="Introduction" id="{a3663388-2a2e-7c52-6e98-1522b8d6ed61}">
+        <p14:section name="Introduction" id="{4f0a9588-5c06-ece2-bdf6-4f09e3f6ae6b}">
           <p14:sldIdLst>
             <p14:sldId id="256"/>
           </p14:sldIdLst>
         </p14:section>
-        <p14:section name="The opportunity" id="{05c7b7f5-c2e4-2506-09b2-411a18096757}">
+        <p14:section name="The opportunity" id="{d360f4df-ac77-e636-2d3e-76ae4b34b50a}">
           <p14:sldIdLst>
             <p14:sldId id="257"/>
           </p14:sldIdLst>
         </p14:section>
-        <p14:section name="The solution" id="{d477de28-a426-97e2-357d-4de0930143c2}">
+        <p14:section name="The solution" id="{93f16b12-986e-9da0-8fda-6356e06936c7}">
           <p14:sldIdLst>
             <p14:sldId id="258"/>
             <p14:sldId id="259"/>
           </p14:sldIdLst>
         </p14:section>
-        <p14:section name="Investment" id="{d4f04f5b-8984-3277-715a-6e4c6f9679e4}">
+        <p14:section name="Investment" id="{b8ca40ff-1aa3-162d-efa6-340ff236ec06}">
           <p14:sldIdLst>
             <p14:sldId id="260"/>
             <p14:sldId id="261"/>
             <p14:sldId id="262"/>
           </p14:sldIdLst>
         </p14:section>
-        <p14:section name="The decision" id="{9875e509-3cdc-f43f-1fbe-ac72727b6939}">
+        <p14:section name="The decision" id="{05603e9b-6be0-7e41-bd92-1950d225fe96}">
           <p14:sldIdLst>
             <p14:sldId id="263"/>
           </p14:sldIdLst>
@@ -986,7 +986,7 @@
           <a:p>
             <a:r>
               <a:rPr lang="en-US" dirty="0"/>
-              <a:t>Stress that this is an illustrative scenario, not a forecast: actual results depend on patient conversion, treatment uptake and average treatment value. Only the 100 enquiries comes from the clinic. The other inputs are examples to replace with her real numbers. At these figures, 60 enquiries a month don't book; bringing back 20% of them is 12 patients, about ₹96,000 a month, and a single patient brought back covers the ₹2,999 fee.</a:t>
+              <a:t>Walk it left to right. 100 enquiries; if 4 in 10 book today, 60 don't. If the receptionist brings back 1 in 5 of those, that's 12 patients. With a ₹500 consultation and half going on to ₹15,000 treatment, each booked patient is worth about ₹8,000, so 12 patients is about ₹96,000 a month. These are example figures; we use the clinic's own numbers at onboarding. One patient brought back covers the ₹2,999 fee.</a:t>
             </a:r>
             <a:endParaRPr lang="en-US" dirty="0"/>
           </a:p>
@@ -2959,18 +2959,54 @@
       </p:sp>
       <p:sp>
         <p:nvSpPr>
-          <p:cNvPr id="20" name="Shape 14"/>
-          <p:cNvSpPr/>
+          <p:cNvPr id="20" name="Text 14"/>
+          <p:cNvSpPr txBox="1"/>
           <p:nvPr/>
         </p:nvSpPr>
         <p:spPr>
           <a:xfrm>
             <a:off x="548640" y="3291840"/>
-            <a:ext cx="5486400" cy="548640"/>
+            <a:ext cx="5486400" cy="274320"/>
+          </a:xfrm>
+          <a:prstGeom prst="rect">
+            <a:avLst/>
+          </a:prstGeom>
+          <a:noFill/>
+          <a:ln/>
+        </p:spPr>
+        <p:txBody>
+          <a:bodyPr wrap="square" lIns="0" tIns="0" rIns="0" bIns="0" rtlCol="0" anchor="t"/>
+          <a:lstStyle/>
+          <a:p>
+            <a:pPr indent="0" marL="0">
+              <a:buNone/>
+            </a:pPr>
+            <a:r>
+              <a:rPr lang="en-US" sz="1100" b="1" spc="150" kern="0" dirty="0">
+                <a:solidFill>
+                  <a:schemeClr val="accent1"/>
+                </a:solidFill>
+              </a:rPr>
+              <a:t>WHERE ENQUIRIES ARE LOST</a:t>
+            </a:r>
+            <a:endParaRPr lang="en-US" sz="1100" dirty="0"/>
+          </a:p>
+        </p:txBody>
+      </p:sp>
+      <p:sp>
+        <p:nvSpPr>
+          <p:cNvPr id="21" name="Shape 15"/>
+          <p:cNvSpPr/>
+          <p:nvPr/>
+        </p:nvSpPr>
+        <p:spPr>
+          <a:xfrm>
+            <a:off x="548640" y="3657600"/>
+            <a:ext cx="5486400" cy="493776"/>
           </a:xfrm>
           <a:prstGeom prst="roundRect">
             <a:avLst>
-              <a:gd name="adj" fmla="val 16667"/>
+              <a:gd name="adj" fmla="val 18519"/>
             </a:avLst>
           </a:prstGeom>
           <a:solidFill>
@@ -2981,14 +3017,14 @@
       </p:sp>
       <p:sp>
         <p:nvSpPr>
-          <p:cNvPr id="21" name="Text 15"/>
+          <p:cNvPr id="22" name="Text 16"/>
           <p:cNvSpPr txBox="1"/>
           <p:nvPr/>
         </p:nvSpPr>
         <p:spPr>
           <a:xfrm>
-            <a:off x="548640" y="3291840"/>
-            <a:ext cx="5486400" cy="548640"/>
+            <a:off x="548640" y="3657600"/>
+            <a:ext cx="5486400" cy="493776"/>
           </a:xfrm>
           <a:prstGeom prst="rect">
             <a:avLst/>
@@ -3017,18 +3053,18 @@
       </p:sp>
       <p:sp>
         <p:nvSpPr>
-          <p:cNvPr id="22" name="Shape 16"/>
-          <p:cNvSpPr/>
-          <p:nvPr/>
-        </p:nvSpPr>
-        <p:spPr>
-          <a:xfrm>
-            <a:off x="960120" y="3950208"/>
-            <a:ext cx="4663440" cy="548640"/>
+          <p:cNvPr id="23" name="Shape 17"/>
+          <p:cNvSpPr/>
+          <p:nvPr/>
+        </p:nvSpPr>
+        <p:spPr>
+          <a:xfrm>
+            <a:off x="960120" y="4242816"/>
+            <a:ext cx="4663440" cy="493776"/>
           </a:xfrm>
           <a:prstGeom prst="roundRect">
             <a:avLst>
-              <a:gd name="adj" fmla="val 16667"/>
+              <a:gd name="adj" fmla="val 18519"/>
             </a:avLst>
           </a:prstGeom>
           <a:solidFill>
@@ -3039,14 +3075,14 @@
       </p:sp>
       <p:sp>
         <p:nvSpPr>
-          <p:cNvPr id="23" name="Text 17"/>
+          <p:cNvPr id="24" name="Text 18"/>
           <p:cNvSpPr txBox="1"/>
           <p:nvPr/>
         </p:nvSpPr>
         <p:spPr>
           <a:xfrm>
-            <a:off x="960120" y="3950208"/>
-            <a:ext cx="4663440" cy="548640"/>
+            <a:off x="960120" y="4242816"/>
+            <a:ext cx="4663440" cy="493776"/>
           </a:xfrm>
           <a:prstGeom prst="rect">
             <a:avLst/>
@@ -3075,18 +3111,18 @@
       </p:sp>
       <p:sp>
         <p:nvSpPr>
-          <p:cNvPr id="24" name="Shape 18"/>
-          <p:cNvSpPr/>
-          <p:nvPr/>
-        </p:nvSpPr>
-        <p:spPr>
-          <a:xfrm>
-            <a:off x="1371600" y="4608576"/>
-            <a:ext cx="3840480" cy="548640"/>
+          <p:cNvPr id="25" name="Shape 19"/>
+          <p:cNvSpPr/>
+          <p:nvPr/>
+        </p:nvSpPr>
+        <p:spPr>
+          <a:xfrm>
+            <a:off x="1371600" y="4828032"/>
+            <a:ext cx="3840480" cy="493776"/>
           </a:xfrm>
           <a:prstGeom prst="roundRect">
             <a:avLst>
-              <a:gd name="adj" fmla="val 16667"/>
+              <a:gd name="adj" fmla="val 18519"/>
             </a:avLst>
           </a:prstGeom>
           <a:solidFill>
@@ -3097,14 +3133,14 @@
       </p:sp>
       <p:sp>
         <p:nvSpPr>
-          <p:cNvPr id="25" name="Text 19"/>
+          <p:cNvPr id="26" name="Text 20"/>
           <p:cNvSpPr txBox="1"/>
           <p:nvPr/>
         </p:nvSpPr>
         <p:spPr>
           <a:xfrm>
-            <a:off x="1371600" y="4608576"/>
-            <a:ext cx="3840480" cy="548640"/>
+            <a:off x="1371600" y="4828032"/>
+            <a:ext cx="3840480" cy="493776"/>
           </a:xfrm>
           <a:prstGeom prst="rect">
             <a:avLst/>
@@ -3133,18 +3169,18 @@
       </p:sp>
       <p:sp>
         <p:nvSpPr>
-          <p:cNvPr id="26" name="Shape 20"/>
-          <p:cNvSpPr/>
-          <p:nvPr/>
-        </p:nvSpPr>
-        <p:spPr>
-          <a:xfrm>
-            <a:off x="1783080" y="5266944"/>
-            <a:ext cx="3017520" cy="548640"/>
+          <p:cNvPr id="27" name="Shape 21"/>
+          <p:cNvSpPr/>
+          <p:nvPr/>
+        </p:nvSpPr>
+        <p:spPr>
+          <a:xfrm>
+            <a:off x="1783080" y="5413248"/>
+            <a:ext cx="3017520" cy="493776"/>
           </a:xfrm>
           <a:prstGeom prst="roundRect">
             <a:avLst>
-              <a:gd name="adj" fmla="val 16667"/>
+              <a:gd name="adj" fmla="val 18519"/>
             </a:avLst>
           </a:prstGeom>
           <a:solidFill>
@@ -3160,73 +3196,37 @@
       </p:sp>
       <p:sp>
         <p:nvSpPr>
-          <p:cNvPr id="27" name="Text 21"/>
-          <p:cNvSpPr txBox="1"/>
-          <p:nvPr/>
-        </p:nvSpPr>
-        <p:spPr>
-          <a:xfrm>
-            <a:off x="1783080" y="5266944"/>
-            <a:ext cx="3017520" cy="548640"/>
-          </a:xfrm>
-          <a:prstGeom prst="rect">
-            <a:avLst/>
-          </a:prstGeom>
-          <a:noFill/>
-          <a:ln/>
-        </p:spPr>
-        <p:txBody>
-          <a:bodyPr wrap="square" lIns="0" tIns="0" rIns="0" bIns="0" rtlCol="0" anchor="ctr"/>
-          <a:lstStyle/>
-          <a:p>
-            <a:pPr algn="ctr" indent="0" marL="0">
-              <a:buNone/>
-            </a:pPr>
-            <a:r>
-              <a:rPr lang="en-US" sz="1400" b="1" dirty="0">
-                <a:solidFill>
-                  <a:schemeClr val="accent6"/>
-                </a:solidFill>
-              </a:rPr>
-              <a:t>Revenue that never arrives</a:t>
-            </a:r>
-            <a:endParaRPr lang="en-US" sz="1400" dirty="0"/>
-          </a:p>
-        </p:txBody>
-      </p:sp>
-      <p:sp>
-        <p:nvSpPr>
           <p:cNvPr id="28" name="Text 22"/>
           <p:cNvSpPr txBox="1"/>
           <p:nvPr/>
         </p:nvSpPr>
         <p:spPr>
           <a:xfrm>
-            <a:off x="548640" y="5943600"/>
-            <a:ext cx="5943600" cy="274320"/>
-          </a:xfrm>
-          <a:prstGeom prst="rect">
-            <a:avLst/>
-          </a:prstGeom>
-          <a:noFill/>
-          <a:ln/>
-        </p:spPr>
-        <p:txBody>
-          <a:bodyPr wrap="square" lIns="0" tIns="0" rIns="0" bIns="0" rtlCol="0" anchor="t"/>
-          <a:lstStyle/>
-          <a:p>
-            <a:pPr indent="0" marL="0">
-              <a:buNone/>
-            </a:pPr>
-            <a:r>
-              <a:rPr lang="en-US" sz="1100" dirty="0">
-                <a:solidFill>
-                  <a:schemeClr val="tx2"/>
-                </a:solidFill>
-              </a:rPr>
-              <a:t>Figures shared by the clinic. How many book is measured from day one.</a:t>
-            </a:r>
-            <a:endParaRPr lang="en-US" sz="1100" dirty="0"/>
+            <a:off x="1783080" y="5413248"/>
+            <a:ext cx="3017520" cy="493776"/>
+          </a:xfrm>
+          <a:prstGeom prst="rect">
+            <a:avLst/>
+          </a:prstGeom>
+          <a:noFill/>
+          <a:ln/>
+        </p:spPr>
+        <p:txBody>
+          <a:bodyPr wrap="square" lIns="0" tIns="0" rIns="0" bIns="0" rtlCol="0" anchor="ctr"/>
+          <a:lstStyle/>
+          <a:p>
+            <a:pPr algn="ctr" indent="0" marL="0">
+              <a:buNone/>
+            </a:pPr>
+            <a:r>
+              <a:rPr lang="en-US" sz="1400" b="1" dirty="0">
+                <a:solidFill>
+                  <a:schemeClr val="accent6"/>
+                </a:solidFill>
+              </a:rPr>
+              <a:t>Revenue that never arrives</a:t>
+            </a:r>
+            <a:endParaRPr lang="en-US" sz="1400" dirty="0"/>
           </a:p>
         </p:txBody>
       </p:sp>
@@ -3238,8 +3238,8 @@
         </p:nvSpPr>
         <p:spPr>
           <a:xfrm>
-            <a:off x="6675120" y="3291840"/>
-            <a:ext cx="4965192" cy="2743200"/>
+            <a:off x="548640" y="5989320"/>
+            <a:ext cx="5943600" cy="228600"/>
           </a:xfrm>
           <a:prstGeom prst="rect">
             <a:avLst/>
@@ -3255,124 +3255,506 @@
               <a:buNone/>
             </a:pPr>
             <a:r>
+              <a:rPr lang="en-US" sz="1100" dirty="0">
+                <a:solidFill>
+                  <a:schemeClr val="tx2"/>
+                </a:solidFill>
+              </a:rPr>
+              <a:t>Figures shared by the clinic.</a:t>
+            </a:r>
+            <a:endParaRPr lang="en-US" sz="1100" dirty="0"/>
+          </a:p>
+        </p:txBody>
+      </p:sp>
+      <p:sp>
+        <p:nvSpPr>
+          <p:cNvPr id="30" name="leak-0"/>
+          <p:cNvSpPr/>
+          <p:nvPr/>
+        </p:nvSpPr>
+        <p:spPr>
+          <a:xfrm>
+            <a:off x="6675120" y="3657600"/>
+            <a:ext cx="2414016" cy="1097280"/>
+          </a:xfrm>
+          <a:prstGeom prst="roundRect">
+            <a:avLst>
+              <a:gd name="adj" fmla="val 10000"/>
+            </a:avLst>
+          </a:prstGeom>
+          <a:solidFill>
+            <a:schemeClr val="bg1"/>
+          </a:solidFill>
+          <a:ln w="9525">
+            <a:solidFill>
+              <a:srgbClr val="D5DEDB"/>
+            </a:solidFill>
+            <a:prstDash val="solid"/>
+          </a:ln>
+        </p:spPr>
+      </p:sp>
+      <p:pic>
+        <p:nvPicPr>
+          <p:cNvPr id="31" name="Image 4" descr="preencoded.png">    </p:cNvPr>
+          <p:cNvPicPr>
+            <a:picLocks noChangeAspect="1"/>
+          </p:cNvPicPr>
+          <p:nvPr/>
+        </p:nvPicPr>
+        <p:blipFill>
+          <a:blip r:embed="rId5"/>
+          <a:stretch>
+            <a:fillRect/>
+          </a:stretch>
+        </p:blipFill>
+        <p:spPr>
+          <a:xfrm>
+            <a:off x="6858000" y="3840480"/>
+            <a:ext cx="274320" cy="274320"/>
+          </a:xfrm>
+          <a:prstGeom prst="rect">
+            <a:avLst/>
+          </a:prstGeom>
+        </p:spPr>
+      </p:pic>
+      <p:sp>
+        <p:nvSpPr>
+          <p:cNvPr id="32" name="Text 25"/>
+          <p:cNvSpPr txBox="1"/>
+          <p:nvPr/>
+        </p:nvSpPr>
+        <p:spPr>
+          <a:xfrm>
+            <a:off x="7223760" y="3813048"/>
+            <a:ext cx="1783080" cy="329184"/>
+          </a:xfrm>
+          <a:prstGeom prst="rect">
+            <a:avLst/>
+          </a:prstGeom>
+          <a:noFill/>
+          <a:ln/>
+        </p:spPr>
+        <p:txBody>
+          <a:bodyPr wrap="square" lIns="0" tIns="0" rIns="0" bIns="0" rtlCol="0" anchor="ctr"/>
+          <a:lstStyle/>
+          <a:p>
+            <a:pPr indent="0" marL="0">
+              <a:buNone/>
+            </a:pPr>
+            <a:r>
               <a:rPr lang="en-US" sz="1300" b="1" dirty="0">
                 <a:solidFill>
                   <a:schemeClr val="tx1"/>
                 </a:solidFill>
               </a:rPr>
-              <a:t>Wrong or inconsistent answers</a:t>
+              <a:t>Wrong answers</a:t>
             </a:r>
             <a:endParaRPr lang="en-US" sz="1300" dirty="0"/>
           </a:p>
+        </p:txBody>
+      </p:sp>
+      <p:sp>
+        <p:nvSpPr>
+          <p:cNvPr id="33" name="Text 26"/>
+          <p:cNvSpPr txBox="1"/>
+          <p:nvPr/>
+        </p:nvSpPr>
+        <p:spPr>
+          <a:xfrm>
+            <a:off x="6858000" y="4187952"/>
+            <a:ext cx="2103120" cy="530352"/>
+          </a:xfrm>
+          <a:prstGeom prst="rect">
+            <a:avLst/>
+          </a:prstGeom>
+          <a:noFill/>
+          <a:ln/>
+        </p:spPr>
+        <p:txBody>
+          <a:bodyPr wrap="square" lIns="0" tIns="0" rIns="0" bIns="0" rtlCol="0" anchor="t"/>
+          <a:lstStyle/>
           <a:p>
             <a:pPr indent="0" marL="0">
-              <a:spcAft>
-                <a:spcPts val="1000"/>
-              </a:spcAft>
-              <a:buNone/>
-            </a:pPr>
-            <a:r>
-              <a:rPr lang="en-US" sz="1300" dirty="0">
+              <a:buNone/>
+            </a:pPr>
+            <a:r>
+              <a:rPr lang="en-US" sz="1100" dirty="0">
                 <a:solidFill>
                   <a:schemeClr val="tx2"/>
                 </a:solidFill>
               </a:rPr>
-              <a:t>A patient given the wrong fee or detail may not come back to check.</a:t>
+              <a:t>A wrong fee or detail, and the patient doesn't come back.</a:t>
+            </a:r>
+            <a:endParaRPr lang="en-US" sz="1100" dirty="0"/>
+          </a:p>
+        </p:txBody>
+      </p:sp>
+      <p:sp>
+        <p:nvSpPr>
+          <p:cNvPr id="34" name="leak-1"/>
+          <p:cNvSpPr/>
+          <p:nvPr/>
+        </p:nvSpPr>
+        <p:spPr>
+          <a:xfrm>
+            <a:off x="9226296" y="3657600"/>
+            <a:ext cx="2414016" cy="1097280"/>
+          </a:xfrm>
+          <a:prstGeom prst="roundRect">
+            <a:avLst>
+              <a:gd name="adj" fmla="val 10000"/>
+            </a:avLst>
+          </a:prstGeom>
+          <a:solidFill>
+            <a:schemeClr val="bg1"/>
+          </a:solidFill>
+          <a:ln w="9525">
+            <a:solidFill>
+              <a:srgbClr val="D5DEDB"/>
+            </a:solidFill>
+            <a:prstDash val="solid"/>
+          </a:ln>
+        </p:spPr>
+      </p:sp>
+      <p:pic>
+        <p:nvPicPr>
+          <p:cNvPr id="35" name="Image 5" descr="preencoded.png">    </p:cNvPr>
+          <p:cNvPicPr>
+            <a:picLocks noChangeAspect="1"/>
+          </p:cNvPicPr>
+          <p:nvPr/>
+        </p:nvPicPr>
+        <p:blipFill>
+          <a:blip r:embed="rId6"/>
+          <a:stretch>
+            <a:fillRect/>
+          </a:stretch>
+        </p:blipFill>
+        <p:spPr>
+          <a:xfrm>
+            <a:off x="9409176" y="3840480"/>
+            <a:ext cx="274320" cy="274320"/>
+          </a:xfrm>
+          <a:prstGeom prst="rect">
+            <a:avLst/>
+          </a:prstGeom>
+        </p:spPr>
+      </p:pic>
+      <p:sp>
+        <p:nvSpPr>
+          <p:cNvPr id="36" name="Text 28"/>
+          <p:cNvSpPr txBox="1"/>
+          <p:nvPr/>
+        </p:nvSpPr>
+        <p:spPr>
+          <a:xfrm>
+            <a:off x="9774936" y="3813048"/>
+            <a:ext cx="1783080" cy="329184"/>
+          </a:xfrm>
+          <a:prstGeom prst="rect">
+            <a:avLst/>
+          </a:prstGeom>
+          <a:noFill/>
+          <a:ln/>
+        </p:spPr>
+        <p:txBody>
+          <a:bodyPr wrap="square" lIns="0" tIns="0" rIns="0" bIns="0" rtlCol="0" anchor="ctr"/>
+          <a:lstStyle/>
+          <a:p>
+            <a:pPr indent="0" marL="0">
+              <a:buNone/>
+            </a:pPr>
+            <a:r>
+              <a:rPr lang="en-US" sz="1300" b="1" dirty="0">
+                <a:solidFill>
+                  <a:schemeClr val="tx1"/>
+                </a:solidFill>
+              </a:rPr>
+              <a:t>No clear next step</a:t>
             </a:r>
             <a:endParaRPr lang="en-US" sz="1300" dirty="0"/>
           </a:p>
+        </p:txBody>
+      </p:sp>
+      <p:sp>
+        <p:nvSpPr>
+          <p:cNvPr id="37" name="Text 29"/>
+          <p:cNvSpPr txBox="1"/>
+          <p:nvPr/>
+        </p:nvSpPr>
+        <p:spPr>
+          <a:xfrm>
+            <a:off x="9409176" y="4187952"/>
+            <a:ext cx="2103120" cy="530352"/>
+          </a:xfrm>
+          <a:prstGeom prst="rect">
+            <a:avLst/>
+          </a:prstGeom>
+          <a:noFill/>
+          <a:ln/>
+        </p:spPr>
+        <p:txBody>
+          <a:bodyPr wrap="square" lIns="0" tIns="0" rIns="0" bIns="0" rtlCol="0" anchor="t"/>
+          <a:lstStyle/>
           <a:p>
             <a:pPr indent="0" marL="0">
               <a:buNone/>
             </a:pPr>
             <a:r>
+              <a:rPr lang="en-US" sz="1100" dirty="0">
+                <a:solidFill>
+                  <a:schemeClr val="tx2"/>
+                </a:solidFill>
+              </a:rPr>
+              <a:t>Without location and need, the right consultation isn't offered.</a:t>
+            </a:r>
+            <a:endParaRPr lang="en-US" sz="1100" dirty="0"/>
+          </a:p>
+        </p:txBody>
+      </p:sp>
+      <p:sp>
+        <p:nvSpPr>
+          <p:cNvPr id="38" name="leak-2"/>
+          <p:cNvSpPr/>
+          <p:nvPr/>
+        </p:nvSpPr>
+        <p:spPr>
+          <a:xfrm>
+            <a:off x="6675120" y="4864608"/>
+            <a:ext cx="2414016" cy="1097280"/>
+          </a:xfrm>
+          <a:prstGeom prst="roundRect">
+            <a:avLst>
+              <a:gd name="adj" fmla="val 10000"/>
+            </a:avLst>
+          </a:prstGeom>
+          <a:solidFill>
+            <a:schemeClr val="bg1"/>
+          </a:solidFill>
+          <a:ln w="9525">
+            <a:solidFill>
+              <a:srgbClr val="D5DEDB"/>
+            </a:solidFill>
+            <a:prstDash val="solid"/>
+          </a:ln>
+        </p:spPr>
+      </p:sp>
+      <p:pic>
+        <p:nvPicPr>
+          <p:cNvPr id="39" name="Image 6" descr="preencoded.png">    </p:cNvPr>
+          <p:cNvPicPr>
+            <a:picLocks noChangeAspect="1"/>
+          </p:cNvPicPr>
+          <p:nvPr/>
+        </p:nvPicPr>
+        <p:blipFill>
+          <a:blip r:embed="rId7"/>
+          <a:stretch>
+            <a:fillRect/>
+          </a:stretch>
+        </p:blipFill>
+        <p:spPr>
+          <a:xfrm>
+            <a:off x="6858000" y="5047488"/>
+            <a:ext cx="274320" cy="274320"/>
+          </a:xfrm>
+          <a:prstGeom prst="rect">
+            <a:avLst/>
+          </a:prstGeom>
+        </p:spPr>
+      </p:pic>
+      <p:sp>
+        <p:nvSpPr>
+          <p:cNvPr id="40" name="Text 31"/>
+          <p:cNvSpPr txBox="1"/>
+          <p:nvPr/>
+        </p:nvSpPr>
+        <p:spPr>
+          <a:xfrm>
+            <a:off x="7223760" y="5020056"/>
+            <a:ext cx="1783080" cy="329184"/>
+          </a:xfrm>
+          <a:prstGeom prst="rect">
+            <a:avLst/>
+          </a:prstGeom>
+          <a:noFill/>
+          <a:ln/>
+        </p:spPr>
+        <p:txBody>
+          <a:bodyPr wrap="square" lIns="0" tIns="0" rIns="0" bIns="0" rtlCol="0" anchor="ctr"/>
+          <a:lstStyle/>
+          <a:p>
+            <a:pPr indent="0" marL="0">
+              <a:buNone/>
+            </a:pPr>
+            <a:r>
               <a:rPr lang="en-US" sz="1300" b="1" dirty="0">
                 <a:solidFill>
                   <a:schemeClr val="tx1"/>
                 </a:solidFill>
               </a:rPr>
-              <a:t>No clear next step</a:t>
+              <a:t>Follow-up slips</a:t>
             </a:r>
             <a:endParaRPr lang="en-US" sz="1300" dirty="0"/>
           </a:p>
+        </p:txBody>
+      </p:sp>
+      <p:sp>
+        <p:nvSpPr>
+          <p:cNvPr id="41" name="Text 32"/>
+          <p:cNvSpPr txBox="1"/>
+          <p:nvPr/>
+        </p:nvSpPr>
+        <p:spPr>
+          <a:xfrm>
+            <a:off x="6858000" y="5394960"/>
+            <a:ext cx="2103120" cy="530352"/>
+          </a:xfrm>
+          <a:prstGeom prst="rect">
+            <a:avLst/>
+          </a:prstGeom>
+          <a:noFill/>
+          <a:ln/>
+        </p:spPr>
+        <p:txBody>
+          <a:bodyPr wrap="square" lIns="0" tIns="0" rIns="0" bIns="0" rtlCol="0" anchor="t"/>
+          <a:lstStyle/>
           <a:p>
             <a:pPr indent="0" marL="0">
-              <a:spcAft>
-                <a:spcPts val="1000"/>
-              </a:spcAft>
-              <a:buNone/>
-            </a:pPr>
-            <a:r>
-              <a:rPr lang="en-US" sz="1300" dirty="0">
+              <a:buNone/>
+            </a:pPr>
+            <a:r>
+              <a:rPr lang="en-US" sz="1100" dirty="0">
                 <a:solidFill>
                   <a:schemeClr val="tx2"/>
                 </a:solidFill>
               </a:rPr>
-              <a:t>Without location and need, the right consultation isn't offered.</a:t>
+              <a:t>Without a call list, follow-up depends on memory.</a:t>
+            </a:r>
+            <a:endParaRPr lang="en-US" sz="1100" dirty="0"/>
+          </a:p>
+        </p:txBody>
+      </p:sp>
+      <p:sp>
+        <p:nvSpPr>
+          <p:cNvPr id="42" name="leak-3"/>
+          <p:cNvSpPr/>
+          <p:nvPr/>
+        </p:nvSpPr>
+        <p:spPr>
+          <a:xfrm>
+            <a:off x="9226296" y="4864608"/>
+            <a:ext cx="2414016" cy="1097280"/>
+          </a:xfrm>
+          <a:prstGeom prst="roundRect">
+            <a:avLst>
+              <a:gd name="adj" fmla="val 10000"/>
+            </a:avLst>
+          </a:prstGeom>
+          <a:solidFill>
+            <a:schemeClr val="bg1"/>
+          </a:solidFill>
+          <a:ln w="9525">
+            <a:solidFill>
+              <a:srgbClr val="D5DEDB"/>
+            </a:solidFill>
+            <a:prstDash val="solid"/>
+          </a:ln>
+        </p:spPr>
+      </p:sp>
+      <p:pic>
+        <p:nvPicPr>
+          <p:cNvPr id="43" name="Image 7" descr="preencoded.png">    </p:cNvPr>
+          <p:cNvPicPr>
+            <a:picLocks noChangeAspect="1"/>
+          </p:cNvPicPr>
+          <p:nvPr/>
+        </p:nvPicPr>
+        <p:blipFill>
+          <a:blip r:embed="rId8"/>
+          <a:stretch>
+            <a:fillRect/>
+          </a:stretch>
+        </p:blipFill>
+        <p:spPr>
+          <a:xfrm>
+            <a:off x="9409176" y="5047488"/>
+            <a:ext cx="274320" cy="274320"/>
+          </a:xfrm>
+          <a:prstGeom prst="rect">
+            <a:avLst/>
+          </a:prstGeom>
+        </p:spPr>
+      </p:pic>
+      <p:sp>
+        <p:nvSpPr>
+          <p:cNvPr id="44" name="Text 34"/>
+          <p:cNvSpPr txBox="1"/>
+          <p:nvPr/>
+        </p:nvSpPr>
+        <p:spPr>
+          <a:xfrm>
+            <a:off x="9774936" y="5020056"/>
+            <a:ext cx="1783080" cy="329184"/>
+          </a:xfrm>
+          <a:prstGeom prst="rect">
+            <a:avLst/>
+          </a:prstGeom>
+          <a:noFill/>
+          <a:ln/>
+        </p:spPr>
+        <p:txBody>
+          <a:bodyPr wrap="square" lIns="0" tIns="0" rIns="0" bIns="0" rtlCol="0" anchor="ctr"/>
+          <a:lstStyle/>
+          <a:p>
+            <a:pPr indent="0" marL="0">
+              <a:buNone/>
+            </a:pPr>
+            <a:r>
+              <a:rPr lang="en-US" sz="1300" b="1" dirty="0">
+                <a:solidFill>
+                  <a:schemeClr val="tx1"/>
+                </a:solidFill>
+              </a:rPr>
+              <a:t>No view of what works</a:t>
             </a:r>
             <a:endParaRPr lang="en-US" sz="1300" dirty="0"/>
           </a:p>
+        </p:txBody>
+      </p:sp>
+      <p:sp>
+        <p:nvSpPr>
+          <p:cNvPr id="45" name="Text 35"/>
+          <p:cNvSpPr txBox="1"/>
+          <p:nvPr/>
+        </p:nvSpPr>
+        <p:spPr>
+          <a:xfrm>
+            <a:off x="9409176" y="5394960"/>
+            <a:ext cx="2103120" cy="530352"/>
+          </a:xfrm>
+          <a:prstGeom prst="rect">
+            <a:avLst/>
+          </a:prstGeom>
+          <a:noFill/>
+          <a:ln/>
+        </p:spPr>
+        <p:txBody>
+          <a:bodyPr wrap="square" lIns="0" tIns="0" rIns="0" bIns="0" rtlCol="0" anchor="t"/>
+          <a:lstStyle/>
           <a:p>
             <a:pPr indent="0" marL="0">
               <a:buNone/>
             </a:pPr>
             <a:r>
-              <a:rPr lang="en-US" sz="1300" b="1" dirty="0">
-                <a:solidFill>
-                  <a:schemeClr val="tx1"/>
-                </a:solidFill>
-              </a:rPr>
-              <a:t>Non-bookers fade away</a:t>
-            </a:r>
-            <a:endParaRPr lang="en-US" sz="1300" dirty="0"/>
-          </a:p>
-          <a:p>
-            <a:pPr indent="0" marL="0">
-              <a:spcAft>
-                <a:spcPts val="1000"/>
-              </a:spcAft>
-              <a:buNone/>
-            </a:pPr>
-            <a:r>
-              <a:rPr lang="en-US" sz="1300" dirty="0">
+              <a:rPr lang="en-US" sz="1100" dirty="0">
                 <a:solidFill>
                   <a:schemeClr val="tx2"/>
                 </a:solidFill>
               </a:rPr>
-              <a:t>Without a call list, follow-up depends on memory.</a:t>
-            </a:r>
-            <a:endParaRPr lang="en-US" sz="1300" dirty="0"/>
-          </a:p>
-          <a:p>
-            <a:pPr indent="0" marL="0">
-              <a:buNone/>
-            </a:pPr>
-            <a:r>
-              <a:rPr lang="en-US" sz="1300" b="1" dirty="0">
-                <a:solidFill>
-                  <a:schemeClr val="tx1"/>
-                </a:solidFill>
-              </a:rPr>
-              <a:t>No view of what works</a:t>
-            </a:r>
-            <a:endParaRPr lang="en-US" sz="1300" dirty="0"/>
-          </a:p>
-          <a:p>
-            <a:pPr indent="0" marL="0">
-              <a:spcAft>
-                <a:spcPts val="1000"/>
-              </a:spcAft>
-              <a:buNone/>
-            </a:pPr>
-            <a:r>
-              <a:rPr lang="en-US" sz="1300" dirty="0">
-                <a:solidFill>
-                  <a:schemeClr val="tx2"/>
-                </a:solidFill>
-              </a:rPr>
               <a:t>No enquiry-to-appointment numbers for each campaign.</a:t>
             </a:r>
-            <a:endParaRPr lang="en-US" sz="1300" dirty="0"/>
+            <a:endParaRPr lang="en-US" sz="1100" dirty="0"/>
           </a:p>
         </p:txBody>
       </p:sp>
@@ -6686,7 +7068,7 @@
                   <a:schemeClr val="tx1"/>
                 </a:solidFill>
               </a:rPr>
-              <a:t>Your WhatsApp number connected, replacing the Meta AI bot</a:t>
+              <a:t>WhatsApp number connected, replacing the Meta AI bot</a:t>
             </a:r>
             <a:endParaRPr lang="en-US" sz="1300" dirty="0"/>
           </a:p>
@@ -7224,192 +7606,13 @@
       </p:sp>
       <p:sp>
         <p:nvSpPr>
-          <p:cNvPr id="4" name="Text 2"/>
-          <p:cNvSpPr txBox="1"/>
-          <p:nvPr/>
-        </p:nvSpPr>
-        <p:spPr>
-          <a:xfrm>
-            <a:off x="548640" y="2286000"/>
-            <a:ext cx="5577840" cy="1143000"/>
-          </a:xfrm>
-          <a:prstGeom prst="rect">
-            <a:avLst/>
-          </a:prstGeom>
-          <a:noFill/>
-          <a:ln/>
-        </p:spPr>
-        <p:txBody>
-          <a:bodyPr wrap="square" lIns="0" tIns="0" rIns="0" bIns="0" rtlCol="0" anchor="t"/>
-          <a:lstStyle/>
-          <a:p>
-            <a:pPr indent="0" marL="0">
-              <a:buNone/>
-            </a:pPr>
-            <a:r>
-              <a:rPr lang="en-US" sz="1400" b="1" dirty="0">
-                <a:solidFill>
-                  <a:schemeClr val="tx1"/>
-                </a:solidFill>
-              </a:rPr>
-              <a:t>Value per patient</a:t>
-            </a:r>
-            <a:endParaRPr lang="en-US" sz="1400" dirty="0"/>
-          </a:p>
-          <a:p>
-            <a:pPr indent="0" marL="0">
-              <a:spcAft>
-                <a:spcPts val="800"/>
-              </a:spcAft>
-              <a:buNone/>
-            </a:pPr>
-            <a:r>
-              <a:rPr lang="en-US" sz="1400" dirty="0">
-                <a:solidFill>
-                  <a:schemeClr val="tx2"/>
-                </a:solidFill>
-              </a:rPr>
-              <a:t>= consultation fee + (treatment rate × average treatment value)</a:t>
-            </a:r>
-            <a:endParaRPr lang="en-US" sz="1400" dirty="0"/>
-          </a:p>
-          <a:p>
-            <a:pPr indent="0" marL="0">
-              <a:buNone/>
-            </a:pPr>
-            <a:r>
-              <a:rPr lang="en-US" sz="1400" b="1" dirty="0">
-                <a:solidFill>
-                  <a:schemeClr val="tx1"/>
-                </a:solidFill>
-              </a:rPr>
-              <a:t>Revenue recovered each month</a:t>
-            </a:r>
-            <a:endParaRPr lang="en-US" sz="1400" dirty="0"/>
-          </a:p>
-          <a:p>
-            <a:pPr indent="0" marL="0">
-              <a:buNone/>
-            </a:pPr>
-            <a:r>
-              <a:rPr lang="en-US" sz="1400" dirty="0">
-                <a:solidFill>
-                  <a:schemeClr val="tx2"/>
-                </a:solidFill>
-              </a:rPr>
-              <a:t>= enquiries not booked × share brought back × value per patient</a:t>
-            </a:r>
-            <a:endParaRPr lang="en-US" sz="1400" dirty="0"/>
-          </a:p>
-        </p:txBody>
-      </p:sp>
-      <p:sp>
-        <p:nvSpPr>
-          <p:cNvPr id="5" name="illustrative-notice"/>
-          <p:cNvSpPr/>
-          <p:nvPr/>
-        </p:nvSpPr>
-        <p:spPr>
-          <a:xfrm>
-            <a:off x="548640" y="1463040"/>
-            <a:ext cx="11091672" cy="640080"/>
-          </a:xfrm>
-          <a:prstGeom prst="roundRect">
-            <a:avLst>
-              <a:gd name="adj" fmla="val 14286"/>
-            </a:avLst>
-          </a:prstGeom>
-          <a:solidFill>
-            <a:schemeClr val="bg1"/>
-          </a:solidFill>
-          <a:ln w="15875">
-            <a:solidFill>
-              <a:schemeClr val="accent3"/>
-            </a:solidFill>
-            <a:prstDash val="solid"/>
-          </a:ln>
-        </p:spPr>
-      </p:sp>
-      <p:pic>
-        <p:nvPicPr>
-          <p:cNvPr id="6" name="Image 0" descr="preencoded.png">    </p:cNvPr>
-          <p:cNvPicPr>
-            <a:picLocks noChangeAspect="1"/>
-          </p:cNvPicPr>
-          <p:nvPr/>
-        </p:nvPicPr>
-        <p:blipFill>
-          <a:blip r:embed="rId1"/>
-          <a:stretch>
-            <a:fillRect/>
-          </a:stretch>
-        </p:blipFill>
-        <p:spPr>
-          <a:xfrm>
-            <a:off x="777240" y="1600200"/>
-            <a:ext cx="365760" cy="365760"/>
-          </a:xfrm>
-          <a:prstGeom prst="rect">
-            <a:avLst/>
-          </a:prstGeom>
-        </p:spPr>
-      </p:pic>
-      <p:sp>
-        <p:nvSpPr>
-          <p:cNvPr id="7" name="Text 4"/>
-          <p:cNvSpPr txBox="1"/>
-          <p:nvPr/>
-        </p:nvSpPr>
-        <p:spPr>
-          <a:xfrm>
-            <a:off x="1325880" y="1463040"/>
-            <a:ext cx="10149840" cy="640080"/>
-          </a:xfrm>
-          <a:prstGeom prst="rect">
-            <a:avLst/>
-          </a:prstGeom>
-          <a:noFill/>
-          <a:ln/>
-        </p:spPr>
-        <p:txBody>
-          <a:bodyPr wrap="square" lIns="0" tIns="0" rIns="0" bIns="0" rtlCol="0" anchor="ctr"/>
-          <a:lstStyle/>
-          <a:p>
-            <a:pPr indent="0" marL="0">
-              <a:buNone/>
-            </a:pPr>
-            <a:r>
-              <a:rPr lang="en-US" sz="1400" b="1" dirty="0">
-                <a:solidFill>
-                  <a:schemeClr val="accent3"/>
-                </a:solidFill>
-              </a:rPr>
-              <a:t>Illustrative scenario only.  </a:t>
-            </a:r>
-            <a:pPr indent="0" marL="0">
-              <a:buNone/>
-            </a:pPr>
-            <a:r>
-              <a:rPr lang="en-US" sz="1400" dirty="0">
-                <a:solidFill>
-                  <a:schemeClr val="tx1"/>
-                </a:solidFill>
-              </a:rPr>
-              <a:t>Actual results depend on patient conversion, treatment uptake and average treatment value. These figures are not a revenue forecast.</a:t>
-            </a:r>
-            <a:endParaRPr lang="en-US" sz="1400" dirty="0"/>
-          </a:p>
-        </p:txBody>
-      </p:sp>
-      <p:sp>
-        <p:nvSpPr>
-          <p:cNvPr id="8" name="Shape 5"/>
-          <p:cNvSpPr/>
-          <p:nvPr/>
-        </p:nvSpPr>
-        <p:spPr>
-          <a:xfrm>
-            <a:off x="548640" y="3474720"/>
+          <p:cNvPr id="4" name="Shape 2"/>
+          <p:cNvSpPr/>
+          <p:nvPr/>
+        </p:nvSpPr>
+        <p:spPr>
+          <a:xfrm>
+            <a:off x="10634472" y="347472"/>
             <a:ext cx="1005840" cy="274320"/>
           </a:xfrm>
           <a:prstGeom prst="roundRect">
@@ -7430,13 +7633,13 @@
       </p:sp>
       <p:sp>
         <p:nvSpPr>
-          <p:cNvPr id="9" name="Text 6"/>
+          <p:cNvPr id="5" name="Text 3"/>
           <p:cNvSpPr txBox="1"/>
           <p:nvPr/>
         </p:nvSpPr>
         <p:spPr>
           <a:xfrm>
-            <a:off x="548640" y="3474720"/>
+            <a:off x="10634472" y="347472"/>
             <a:ext cx="1005840" cy="274320"/>
           </a:xfrm>
           <a:prstGeom prst="rect">
@@ -7469,612 +7672,172 @@
       </p:sp>
       <p:sp>
         <p:nvSpPr>
-          <p:cNvPr id="10" name="Text 7"/>
-          <p:cNvSpPr txBox="1"/>
-          <p:nvPr/>
-        </p:nvSpPr>
-        <p:spPr>
-          <a:xfrm>
-            <a:off x="1691640" y="3474720"/>
-            <a:ext cx="4114800" cy="274320"/>
-          </a:xfrm>
-          <a:prstGeom prst="rect">
-            <a:avLst/>
-          </a:prstGeom>
-          <a:noFill/>
-          <a:ln/>
-        </p:spPr>
-        <p:txBody>
-          <a:bodyPr wrap="square" lIns="0" tIns="0" rIns="0" bIns="0" rtlCol="0" anchor="ctr"/>
-          <a:lstStyle/>
-          <a:p>
-            <a:pPr indent="0" marL="0">
-              <a:buNone/>
-            </a:pPr>
-            <a:r>
-              <a:rPr lang="en-US" sz="1200" dirty="0">
-                <a:solidFill>
-                  <a:schemeClr val="tx2"/>
-                </a:solidFill>
-              </a:rPr>
-              <a:t>Replace with your clinic's numbers</a:t>
-            </a:r>
-            <a:endParaRPr lang="en-US" sz="1200" dirty="0"/>
-          </a:p>
-        </p:txBody>
-      </p:sp>
-      <p:graphicFrame>
-        <p:nvGraphicFramePr>
-          <p:cNvPr id="7" name="Table 0"/>
-          <p:cNvGraphicFramePr>
-            <a:graphicFrameLocks noGrp="1"/>
-          </p:cNvGraphicFramePr>
-          <p:nvPr>
-            <p:extLst>
-              <p:ext uri="{D42A27DB-BD31-4B8C-83A1-F6EECF244321}">
-                <p14:modId xmlns:p14="http://schemas.microsoft.com/office/powerpoint/2010/main" val="1579011935"/>
-              </p:ext>
-            </p:extLst>
-          </p:nvPr>
-        </p:nvGraphicFramePr>
-        <p:xfrm>
-          <a:off x="548640" y="3840480"/>
-          <a:ext cx="5577840" cy="914400"/>
-        </p:xfrm>
-        <a:graphic>
-          <a:graphicData uri="http://schemas.openxmlformats.org/drawingml/2006/table">
-            <a:tbl>
-              <a:tblPr/>
-              <a:tblGrid>
-                <a:gridCol w="3749040"/>
-                <a:gridCol w="1828800"/>
-              </a:tblGrid>
-              <a:tr h="310896">
-                <a:tc>
-                  <a:txBody>
-                    <a:bodyPr/>
-                    <a:lstStyle/>
-                    <a:p>
-                      <a:pPr indent="0" marL="0">
-                        <a:buNone/>
-                      </a:pPr>
-                      <a:r>
-                        <a:rPr lang="en-US" sz="1300" dirty="0">
-                          <a:solidFill>
-                            <a:schemeClr val="tx1"/>
-                          </a:solidFill>
-                        </a:rPr>
-                        <a:t>Enquiries a month</a:t>
-                      </a:r>
-                      <a:endParaRPr lang="en-US" sz="1300" dirty="0"/>
-                    </a:p>
-                  </a:txBody>
-                  <a:tcPr marL="109728" marR="109728" marT="45720" marB="45720">
-                    <a:lnL w="0" cap="flat" cmpd="sng" algn="ctr">
-                      <a:noFill/>
-                    </a:lnL>
-                    <a:lnR w="0" cap="flat" cmpd="sng" algn="ctr">
-                      <a:noFill/>
-                    </a:lnR>
-                    <a:lnT w="0" cap="flat" cmpd="sng" algn="ctr">
-                      <a:noFill/>
-                    </a:lnT>
-                    <a:lnB w="9525" cap="flat" cmpd="sng" algn="ctr">
-                      <a:solidFill>
-                        <a:srgbClr val="D5DEDB"/>
-                      </a:solidFill>
-                      <a:prstDash val="solid"/>
-                      <a:round/>
-                      <a:headEnd type="none" w="med" len="med"/>
-                      <a:tailEnd type="none" w="med" len="med"/>
-                    </a:lnB>
-                    <a:solidFill>
-                      <a:schemeClr val="bg1"/>
-                    </a:solidFill>
-                  </a:tcPr>
-                </a:tc>
-                <a:tc>
-                  <a:txBody>
-                    <a:bodyPr/>
-                    <a:lstStyle/>
-                    <a:p>
-                      <a:pPr indent="0" marL="0">
-                        <a:buNone/>
-                      </a:pPr>
-                      <a:r>
-                        <a:rPr lang="en-US" sz="1300" b="1" dirty="0">
-                          <a:solidFill>
-                            <a:schemeClr val="tx1"/>
-                          </a:solidFill>
-                        </a:rPr>
-                        <a:t>100 (clinic)</a:t>
-                      </a:r>
-                      <a:endParaRPr lang="en-US" sz="1300" dirty="0"/>
-                    </a:p>
-                  </a:txBody>
-                  <a:tcPr marL="109728" marR="109728" marT="45720" marB="45720">
-                    <a:lnL w="0" cap="flat" cmpd="sng" algn="ctr">
-                      <a:noFill/>
-                    </a:lnL>
-                    <a:lnR w="0" cap="flat" cmpd="sng" algn="ctr">
-                      <a:noFill/>
-                    </a:lnR>
-                    <a:lnT w="0" cap="flat" cmpd="sng" algn="ctr">
-                      <a:noFill/>
-                    </a:lnT>
-                    <a:lnB w="9525" cap="flat" cmpd="sng" algn="ctr">
-                      <a:solidFill>
-                        <a:srgbClr val="D5DEDB"/>
-                      </a:solidFill>
-                      <a:prstDash val="solid"/>
-                      <a:round/>
-                      <a:headEnd type="none" w="med" len="med"/>
-                      <a:tailEnd type="none" w="med" len="med"/>
-                    </a:lnB>
-                    <a:solidFill>
-                      <a:schemeClr val="bg1"/>
-                    </a:solidFill>
-                  </a:tcPr>
-                </a:tc>
-              </a:tr>
-              <a:tr h="310896">
-                <a:tc>
-                  <a:txBody>
-                    <a:bodyPr/>
-                    <a:lstStyle/>
-                    <a:p>
-                      <a:pPr indent="0" marL="0">
-                        <a:buNone/>
-                      </a:pPr>
-                      <a:r>
-                        <a:rPr lang="en-US" sz="1300" dirty="0">
-                          <a:solidFill>
-                            <a:schemeClr val="tx1"/>
-                          </a:solidFill>
-                        </a:rPr>
-                        <a:t>Enquiries that book today</a:t>
-                      </a:r>
-                      <a:endParaRPr lang="en-US" sz="1300" dirty="0"/>
-                    </a:p>
-                  </a:txBody>
-                  <a:tcPr marL="109728" marR="109728" marT="45720" marB="45720">
-                    <a:lnL w="0" cap="flat" cmpd="sng" algn="ctr">
-                      <a:noFill/>
-                    </a:lnL>
-                    <a:lnR w="0" cap="flat" cmpd="sng" algn="ctr">
-                      <a:noFill/>
-                    </a:lnR>
-                    <a:lnT w="0" cap="flat" cmpd="sng" algn="ctr">
-                      <a:noFill/>
-                    </a:lnT>
-                    <a:lnB w="9525" cap="flat" cmpd="sng" algn="ctr">
-                      <a:solidFill>
-                        <a:srgbClr val="D5DEDB"/>
-                      </a:solidFill>
-                      <a:prstDash val="solid"/>
-                      <a:round/>
-                      <a:headEnd type="none" w="med" len="med"/>
-                      <a:tailEnd type="none" w="med" len="med"/>
-                    </a:lnB>
-                    <a:solidFill>
-                      <a:schemeClr val="bg1"/>
-                    </a:solidFill>
-                  </a:tcPr>
-                </a:tc>
-                <a:tc>
-                  <a:txBody>
-                    <a:bodyPr/>
-                    <a:lstStyle/>
-                    <a:p>
-                      <a:pPr indent="0" marL="0">
-                        <a:buNone/>
-                      </a:pPr>
-                      <a:r>
-                        <a:rPr lang="en-US" sz="1300" b="1" dirty="0">
-                          <a:solidFill>
-                            <a:schemeClr val="tx1"/>
-                          </a:solidFill>
-                        </a:rPr>
-                        <a:t>40%</a:t>
-                      </a:r>
-                      <a:endParaRPr lang="en-US" sz="1300" dirty="0"/>
-                    </a:p>
-                  </a:txBody>
-                  <a:tcPr marL="109728" marR="109728" marT="45720" marB="45720">
-                    <a:lnL w="0" cap="flat" cmpd="sng" algn="ctr">
-                      <a:noFill/>
-                    </a:lnL>
-                    <a:lnR w="0" cap="flat" cmpd="sng" algn="ctr">
-                      <a:noFill/>
-                    </a:lnR>
-                    <a:lnT w="0" cap="flat" cmpd="sng" algn="ctr">
-                      <a:noFill/>
-                    </a:lnT>
-                    <a:lnB w="9525" cap="flat" cmpd="sng" algn="ctr">
-                      <a:solidFill>
-                        <a:srgbClr val="D5DEDB"/>
-                      </a:solidFill>
-                      <a:prstDash val="solid"/>
-                      <a:round/>
-                      <a:headEnd type="none" w="med" len="med"/>
-                      <a:tailEnd type="none" w="med" len="med"/>
-                    </a:lnB>
-                    <a:solidFill>
-                      <a:schemeClr val="bg1"/>
-                    </a:solidFill>
-                  </a:tcPr>
-                </a:tc>
-              </a:tr>
-              <a:tr h="310896">
-                <a:tc>
-                  <a:txBody>
-                    <a:bodyPr/>
-                    <a:lstStyle/>
-                    <a:p>
-                      <a:pPr indent="0" marL="0">
-                        <a:buNone/>
-                      </a:pPr>
-                      <a:r>
-                        <a:rPr lang="en-US" sz="1300" dirty="0">
-                          <a:solidFill>
-                            <a:schemeClr val="tx1"/>
-                          </a:solidFill>
-                        </a:rPr>
-                        <a:t>Consultation fee</a:t>
-                      </a:r>
-                      <a:endParaRPr lang="en-US" sz="1300" dirty="0"/>
-                    </a:p>
-                  </a:txBody>
-                  <a:tcPr marL="109728" marR="109728" marT="45720" marB="45720">
-                    <a:lnL w="0" cap="flat" cmpd="sng" algn="ctr">
-                      <a:noFill/>
-                    </a:lnL>
-                    <a:lnR w="0" cap="flat" cmpd="sng" algn="ctr">
-                      <a:noFill/>
-                    </a:lnR>
-                    <a:lnT w="0" cap="flat" cmpd="sng" algn="ctr">
-                      <a:noFill/>
-                    </a:lnT>
-                    <a:lnB w="9525" cap="flat" cmpd="sng" algn="ctr">
-                      <a:solidFill>
-                        <a:srgbClr val="D5DEDB"/>
-                      </a:solidFill>
-                      <a:prstDash val="solid"/>
-                      <a:round/>
-                      <a:headEnd type="none" w="med" len="med"/>
-                      <a:tailEnd type="none" w="med" len="med"/>
-                    </a:lnB>
-                    <a:solidFill>
-                      <a:schemeClr val="bg1"/>
-                    </a:solidFill>
-                  </a:tcPr>
-                </a:tc>
-                <a:tc>
-                  <a:txBody>
-                    <a:bodyPr/>
-                    <a:lstStyle/>
-                    <a:p>
-                      <a:pPr indent="0" marL="0">
-                        <a:buNone/>
-                      </a:pPr>
-                      <a:r>
-                        <a:rPr lang="en-US" sz="1300" b="1" dirty="0">
-                          <a:solidFill>
-                            <a:schemeClr val="tx1"/>
-                          </a:solidFill>
-                        </a:rPr>
-                        <a:t>₹500</a:t>
-                      </a:r>
-                      <a:endParaRPr lang="en-US" sz="1300" dirty="0"/>
-                    </a:p>
-                  </a:txBody>
-                  <a:tcPr marL="109728" marR="109728" marT="45720" marB="45720">
-                    <a:lnL w="0" cap="flat" cmpd="sng" algn="ctr">
-                      <a:noFill/>
-                    </a:lnL>
-                    <a:lnR w="0" cap="flat" cmpd="sng" algn="ctr">
-                      <a:noFill/>
-                    </a:lnR>
-                    <a:lnT w="0" cap="flat" cmpd="sng" algn="ctr">
-                      <a:noFill/>
-                    </a:lnT>
-                    <a:lnB w="9525" cap="flat" cmpd="sng" algn="ctr">
-                      <a:solidFill>
-                        <a:srgbClr val="D5DEDB"/>
-                      </a:solidFill>
-                      <a:prstDash val="solid"/>
-                      <a:round/>
-                      <a:headEnd type="none" w="med" len="med"/>
-                      <a:tailEnd type="none" w="med" len="med"/>
-                    </a:lnB>
-                    <a:solidFill>
-                      <a:schemeClr val="bg1"/>
-                    </a:solidFill>
-                  </a:tcPr>
-                </a:tc>
-              </a:tr>
-              <a:tr h="310896">
-                <a:tc>
-                  <a:txBody>
-                    <a:bodyPr/>
-                    <a:lstStyle/>
-                    <a:p>
-                      <a:pPr indent="0" marL="0">
-                        <a:buNone/>
-                      </a:pPr>
-                      <a:r>
-                        <a:rPr lang="en-US" sz="1300" dirty="0">
-                          <a:solidFill>
-                            <a:schemeClr val="tx1"/>
-                          </a:solidFill>
-                        </a:rPr>
-                        <a:t>Consultations that go on to treatment</a:t>
-                      </a:r>
-                      <a:endParaRPr lang="en-US" sz="1300" dirty="0"/>
-                    </a:p>
-                  </a:txBody>
-                  <a:tcPr marL="109728" marR="109728" marT="45720" marB="45720">
-                    <a:lnL w="0" cap="flat" cmpd="sng" algn="ctr">
-                      <a:noFill/>
-                    </a:lnL>
-                    <a:lnR w="0" cap="flat" cmpd="sng" algn="ctr">
-                      <a:noFill/>
-                    </a:lnR>
-                    <a:lnT w="0" cap="flat" cmpd="sng" algn="ctr">
-                      <a:noFill/>
-                    </a:lnT>
-                    <a:lnB w="9525" cap="flat" cmpd="sng" algn="ctr">
-                      <a:solidFill>
-                        <a:srgbClr val="D5DEDB"/>
-                      </a:solidFill>
-                      <a:prstDash val="solid"/>
-                      <a:round/>
-                      <a:headEnd type="none" w="med" len="med"/>
-                      <a:tailEnd type="none" w="med" len="med"/>
-                    </a:lnB>
-                    <a:solidFill>
-                      <a:schemeClr val="bg1"/>
-                    </a:solidFill>
-                  </a:tcPr>
-                </a:tc>
-                <a:tc>
-                  <a:txBody>
-                    <a:bodyPr/>
-                    <a:lstStyle/>
-                    <a:p>
-                      <a:pPr indent="0" marL="0">
-                        <a:buNone/>
-                      </a:pPr>
-                      <a:r>
-                        <a:rPr lang="en-US" sz="1300" b="1" dirty="0">
-                          <a:solidFill>
-                            <a:schemeClr val="tx1"/>
-                          </a:solidFill>
-                        </a:rPr>
-                        <a:t>50%</a:t>
-                      </a:r>
-                      <a:endParaRPr lang="en-US" sz="1300" dirty="0"/>
-                    </a:p>
-                  </a:txBody>
-                  <a:tcPr marL="109728" marR="109728" marT="45720" marB="45720">
-                    <a:lnL w="0" cap="flat" cmpd="sng" algn="ctr">
-                      <a:noFill/>
-                    </a:lnL>
-                    <a:lnR w="0" cap="flat" cmpd="sng" algn="ctr">
-                      <a:noFill/>
-                    </a:lnR>
-                    <a:lnT w="0" cap="flat" cmpd="sng" algn="ctr">
-                      <a:noFill/>
-                    </a:lnT>
-                    <a:lnB w="9525" cap="flat" cmpd="sng" algn="ctr">
-                      <a:solidFill>
-                        <a:srgbClr val="D5DEDB"/>
-                      </a:solidFill>
-                      <a:prstDash val="solid"/>
-                      <a:round/>
-                      <a:headEnd type="none" w="med" len="med"/>
-                      <a:tailEnd type="none" w="med" len="med"/>
-                    </a:lnB>
-                    <a:solidFill>
-                      <a:schemeClr val="bg1"/>
-                    </a:solidFill>
-                  </a:tcPr>
-                </a:tc>
-              </a:tr>
-              <a:tr h="310896">
-                <a:tc>
-                  <a:txBody>
-                    <a:bodyPr/>
-                    <a:lstStyle/>
-                    <a:p>
-                      <a:pPr indent="0" marL="0">
-                        <a:buNone/>
-                      </a:pPr>
-                      <a:r>
-                        <a:rPr lang="en-US" sz="1300" dirty="0">
-                          <a:solidFill>
-                            <a:schemeClr val="tx1"/>
-                          </a:solidFill>
-                        </a:rPr>
-                        <a:t>Average treatment value</a:t>
-                      </a:r>
-                      <a:endParaRPr lang="en-US" sz="1300" dirty="0"/>
-                    </a:p>
-                  </a:txBody>
-                  <a:tcPr marL="109728" marR="109728" marT="45720" marB="45720">
-                    <a:lnL w="0" cap="flat" cmpd="sng" algn="ctr">
-                      <a:noFill/>
-                    </a:lnL>
-                    <a:lnR w="0" cap="flat" cmpd="sng" algn="ctr">
-                      <a:noFill/>
-                    </a:lnR>
-                    <a:lnT w="0" cap="flat" cmpd="sng" algn="ctr">
-                      <a:noFill/>
-                    </a:lnT>
-                    <a:lnB w="9525" cap="flat" cmpd="sng" algn="ctr">
-                      <a:solidFill>
-                        <a:srgbClr val="D5DEDB"/>
-                      </a:solidFill>
-                      <a:prstDash val="solid"/>
-                      <a:round/>
-                      <a:headEnd type="none" w="med" len="med"/>
-                      <a:tailEnd type="none" w="med" len="med"/>
-                    </a:lnB>
-                    <a:solidFill>
-                      <a:schemeClr val="bg1"/>
-                    </a:solidFill>
-                  </a:tcPr>
-                </a:tc>
-                <a:tc>
-                  <a:txBody>
-                    <a:bodyPr/>
-                    <a:lstStyle/>
-                    <a:p>
-                      <a:pPr indent="0" marL="0">
-                        <a:buNone/>
-                      </a:pPr>
-                      <a:r>
-                        <a:rPr lang="en-US" sz="1300" b="1" dirty="0">
-                          <a:solidFill>
-                            <a:schemeClr val="tx1"/>
-                          </a:solidFill>
-                        </a:rPr>
-                        <a:t>₹15,000</a:t>
-                      </a:r>
-                      <a:endParaRPr lang="en-US" sz="1300" dirty="0"/>
-                    </a:p>
-                  </a:txBody>
-                  <a:tcPr marL="109728" marR="109728" marT="45720" marB="45720">
-                    <a:lnL w="0" cap="flat" cmpd="sng" algn="ctr">
-                      <a:noFill/>
-                    </a:lnL>
-                    <a:lnR w="0" cap="flat" cmpd="sng" algn="ctr">
-                      <a:noFill/>
-                    </a:lnR>
-                    <a:lnT w="0" cap="flat" cmpd="sng" algn="ctr">
-                      <a:noFill/>
-                    </a:lnT>
-                    <a:lnB w="9525" cap="flat" cmpd="sng" algn="ctr">
-                      <a:solidFill>
-                        <a:srgbClr val="D5DEDB"/>
-                      </a:solidFill>
-                      <a:prstDash val="solid"/>
-                      <a:round/>
-                      <a:headEnd type="none" w="med" len="med"/>
-                      <a:tailEnd type="none" w="med" len="med"/>
-                    </a:lnB>
-                    <a:solidFill>
-                      <a:schemeClr val="bg1"/>
-                    </a:solidFill>
-                  </a:tcPr>
-                </a:tc>
-              </a:tr>
-              <a:tr h="310896">
-                <a:tc>
-                  <a:txBody>
-                    <a:bodyPr/>
-                    <a:lstStyle/>
-                    <a:p>
-                      <a:pPr indent="0" marL="0">
-                        <a:buNone/>
-                      </a:pPr>
-                      <a:r>
-                        <a:rPr lang="en-US" sz="1300" dirty="0">
-                          <a:solidFill>
-                            <a:schemeClr val="tx1"/>
-                          </a:solidFill>
-                        </a:rPr>
-                        <a:t>Non-bookers brought back</a:t>
-                      </a:r>
-                      <a:endParaRPr lang="en-US" sz="1300" dirty="0"/>
-                    </a:p>
-                  </a:txBody>
-                  <a:tcPr marL="109728" marR="109728" marT="45720" marB="45720">
-                    <a:lnL w="0" cap="flat" cmpd="sng" algn="ctr">
-                      <a:noFill/>
-                    </a:lnL>
-                    <a:lnR w="0" cap="flat" cmpd="sng" algn="ctr">
-                      <a:noFill/>
-                    </a:lnR>
-                    <a:lnT w="0" cap="flat" cmpd="sng" algn="ctr">
-                      <a:noFill/>
-                    </a:lnT>
-                    <a:lnB w="9525" cap="flat" cmpd="sng" algn="ctr">
-                      <a:solidFill>
-                        <a:srgbClr val="D5DEDB"/>
-                      </a:solidFill>
-                      <a:prstDash val="solid"/>
-                      <a:round/>
-                      <a:headEnd type="none" w="med" len="med"/>
-                      <a:tailEnd type="none" w="med" len="med"/>
-                    </a:lnB>
-                    <a:solidFill>
-                      <a:schemeClr val="bg1"/>
-                    </a:solidFill>
-                  </a:tcPr>
-                </a:tc>
-                <a:tc>
-                  <a:txBody>
-                    <a:bodyPr/>
-                    <a:lstStyle/>
-                    <a:p>
-                      <a:pPr indent="0" marL="0">
-                        <a:buNone/>
-                      </a:pPr>
-                      <a:r>
-                        <a:rPr lang="en-US" sz="1300" b="1" dirty="0">
-                          <a:solidFill>
-                            <a:schemeClr val="tx1"/>
-                          </a:solidFill>
-                        </a:rPr>
-                        <a:t>20%</a:t>
-                      </a:r>
-                      <a:endParaRPr lang="en-US" sz="1300" dirty="0"/>
-                    </a:p>
-                  </a:txBody>
-                  <a:tcPr marL="109728" marR="109728" marT="45720" marB="45720">
-                    <a:lnL w="0" cap="flat" cmpd="sng" algn="ctr">
-                      <a:noFill/>
-                    </a:lnL>
-                    <a:lnR w="0" cap="flat" cmpd="sng" algn="ctr">
-                      <a:noFill/>
-                    </a:lnR>
-                    <a:lnT w="0" cap="flat" cmpd="sng" algn="ctr">
-                      <a:noFill/>
-                    </a:lnT>
-                    <a:lnB w="9525" cap="flat" cmpd="sng" algn="ctr">
-                      <a:solidFill>
-                        <a:srgbClr val="D5DEDB"/>
-                      </a:solidFill>
-                      <a:prstDash val="solid"/>
-                      <a:round/>
-                      <a:headEnd type="none" w="med" len="med"/>
-                      <a:tailEnd type="none" w="med" len="med"/>
-                    </a:lnB>
-                    <a:solidFill>
-                      <a:schemeClr val="bg1"/>
-                    </a:solidFill>
-                  </a:tcPr>
-                </a:tc>
-              </a:tr>
-            </a:tbl>
-          </a:graphicData>
-        </a:graphic>
-      </p:graphicFrame>
-      <p:sp>
-        <p:nvSpPr>
-          <p:cNvPr id="12" name="tile-0"/>
-          <p:cNvSpPr/>
-          <p:nvPr/>
-        </p:nvSpPr>
-        <p:spPr>
-          <a:xfrm>
-            <a:off x="6583680" y="2286000"/>
-            <a:ext cx="2423160" cy="1645920"/>
+          <p:cNvPr id="6" name="chain-0"/>
+          <p:cNvSpPr/>
+          <p:nvPr/>
+        </p:nvSpPr>
+        <p:spPr>
+          <a:xfrm>
+            <a:off x="548640" y="1600200"/>
+            <a:ext cx="2514600" cy="1920240"/>
           </a:xfrm>
           <a:prstGeom prst="roundRect">
             <a:avLst>
-              <a:gd name="adj" fmla="val 6667"/>
+              <a:gd name="adj" fmla="val 5714"/>
+            </a:avLst>
+          </a:prstGeom>
+          <a:solidFill>
+            <a:schemeClr val="tx1"/>
+          </a:solidFill>
+          <a:ln/>
+        </p:spPr>
+      </p:sp>
+      <p:sp>
+        <p:nvSpPr>
+          <p:cNvPr id="7" name="Text 5"/>
+          <p:cNvSpPr txBox="1"/>
+          <p:nvPr/>
+        </p:nvSpPr>
+        <p:spPr>
+          <a:xfrm>
+            <a:off x="822960" y="1783080"/>
+            <a:ext cx="2057400" cy="777240"/>
+          </a:xfrm>
+          <a:prstGeom prst="rect">
+            <a:avLst/>
+          </a:prstGeom>
+          <a:noFill/>
+          <a:ln/>
+        </p:spPr>
+        <p:txBody>
+          <a:bodyPr wrap="square" lIns="0" tIns="0" rIns="0" bIns="0" rtlCol="0" anchor="b"/>
+          <a:lstStyle/>
+          <a:p>
+            <a:pPr indent="0" marL="0">
+              <a:buNone/>
+            </a:pPr>
+            <a:r>
+              <a:rPr lang="en-US" sz="4400" b="1" dirty="0">
+                <a:solidFill>
+                  <a:schemeClr val="bg1"/>
+                </a:solidFill>
+              </a:rPr>
+              <a:t>100</a:t>
+            </a:r>
+            <a:endParaRPr lang="en-US" sz="4400" dirty="0"/>
+          </a:p>
+        </p:txBody>
+      </p:sp>
+      <p:sp>
+        <p:nvSpPr>
+          <p:cNvPr id="8" name="Text 6"/>
+          <p:cNvSpPr txBox="1"/>
+          <p:nvPr/>
+        </p:nvSpPr>
+        <p:spPr>
+          <a:xfrm>
+            <a:off x="822960" y="2606040"/>
+            <a:ext cx="2057400" cy="320040"/>
+          </a:xfrm>
+          <a:prstGeom prst="rect">
+            <a:avLst/>
+          </a:prstGeom>
+          <a:noFill/>
+          <a:ln/>
+        </p:spPr>
+        <p:txBody>
+          <a:bodyPr wrap="square" lIns="0" tIns="0" rIns="0" bIns="0" rtlCol="0" anchor="t"/>
+          <a:lstStyle/>
+          <a:p>
+            <a:pPr indent="0" marL="0">
+              <a:buNone/>
+            </a:pPr>
+            <a:r>
+              <a:rPr lang="en-US" sz="1600" b="1" dirty="0">
+                <a:solidFill>
+                  <a:schemeClr val="bg1"/>
+                </a:solidFill>
+              </a:rPr>
+              <a:t>enquiries a month</a:t>
+            </a:r>
+            <a:endParaRPr lang="en-US" sz="1600" dirty="0"/>
+          </a:p>
+        </p:txBody>
+      </p:sp>
+      <p:sp>
+        <p:nvSpPr>
+          <p:cNvPr id="9" name="Text 7"/>
+          <p:cNvSpPr txBox="1"/>
+          <p:nvPr/>
+        </p:nvSpPr>
+        <p:spPr>
+          <a:xfrm>
+            <a:off x="822960" y="2926080"/>
+            <a:ext cx="2057400" cy="457200"/>
+          </a:xfrm>
+          <a:prstGeom prst="rect">
+            <a:avLst/>
+          </a:prstGeom>
+          <a:noFill/>
+          <a:ln/>
+        </p:spPr>
+        <p:txBody>
+          <a:bodyPr wrap="square" lIns="0" tIns="0" rIns="0" bIns="0" rtlCol="0" anchor="t"/>
+          <a:lstStyle/>
+          <a:p>
+            <a:pPr indent="0" marL="0">
+              <a:buNone/>
+            </a:pPr>
+            <a:r>
+              <a:rPr lang="en-US" sz="1200" dirty="0">
+                <a:solidFill>
+                  <a:schemeClr val="accent2"/>
+                </a:solidFill>
+              </a:rPr>
+              <a:t>from your ads</a:t>
+            </a:r>
+            <a:endParaRPr lang="en-US" sz="1200" dirty="0"/>
+          </a:p>
+        </p:txBody>
+      </p:sp>
+      <p:sp>
+        <p:nvSpPr>
+          <p:cNvPr id="10" name="Shape 8"/>
+          <p:cNvSpPr/>
+          <p:nvPr/>
+        </p:nvSpPr>
+        <p:spPr>
+          <a:xfrm>
+            <a:off x="3090672" y="2560320"/>
+            <a:ext cx="265176" cy="0"/>
+          </a:xfrm>
+          <a:prstGeom prst="line">
+            <a:avLst/>
+          </a:prstGeom>
+          <a:noFill/>
+          <a:ln w="15875">
+            <a:solidFill>
+              <a:schemeClr val="tx2"/>
+            </a:solidFill>
+            <a:prstDash val="solid"/>
+            <a:tailEnd type="triangle"/>
+          </a:ln>
+        </p:spPr>
+      </p:sp>
+      <p:sp>
+        <p:nvSpPr>
+          <p:cNvPr id="11" name="chain-1"/>
+          <p:cNvSpPr/>
+          <p:nvPr/>
+        </p:nvSpPr>
+        <p:spPr>
+          <a:xfrm>
+            <a:off x="3383280" y="1600200"/>
+            <a:ext cx="2514600" cy="1920240"/>
+          </a:xfrm>
+          <a:prstGeom prst="roundRect">
+            <a:avLst>
+              <a:gd name="adj" fmla="val 5714"/>
             </a:avLst>
           </a:prstGeom>
           <a:solidFill>
@@ -8090,14 +7853,14 @@
       </p:sp>
       <p:sp>
         <p:nvSpPr>
-          <p:cNvPr id="13" name="Text 9"/>
+          <p:cNvPr id="12" name="Text 10"/>
           <p:cNvSpPr txBox="1"/>
           <p:nvPr/>
         </p:nvSpPr>
         <p:spPr>
           <a:xfrm>
-            <a:off x="6812280" y="2450592"/>
-            <a:ext cx="2011680" cy="640080"/>
+            <a:off x="3657600" y="1783080"/>
+            <a:ext cx="2057400" cy="777240"/>
           </a:xfrm>
           <a:prstGeom prst="rect">
             <a:avLst/>
@@ -8113,27 +7876,27 @@
               <a:buNone/>
             </a:pPr>
             <a:r>
-              <a:rPr lang="en-US" sz="3000" b="1" dirty="0">
+              <a:rPr lang="en-US" sz="4400" b="1" dirty="0">
                 <a:solidFill>
                   <a:schemeClr val="tx1"/>
                 </a:solidFill>
               </a:rPr>
               <a:t>60</a:t>
             </a:r>
-            <a:endParaRPr lang="en-US" sz="3000" dirty="0"/>
-          </a:p>
-        </p:txBody>
-      </p:sp>
-      <p:sp>
-        <p:nvSpPr>
-          <p:cNvPr id="14" name="Text 10"/>
+            <a:endParaRPr lang="en-US" sz="4400" dirty="0"/>
+          </a:p>
+        </p:txBody>
+      </p:sp>
+      <p:sp>
+        <p:nvSpPr>
+          <p:cNvPr id="13" name="Text 11"/>
           <p:cNvSpPr txBox="1"/>
           <p:nvPr/>
         </p:nvSpPr>
         <p:spPr>
           <a:xfrm>
-            <a:off x="6812280" y="3154680"/>
-            <a:ext cx="2011680" cy="685800"/>
+            <a:off x="3657600" y="2606040"/>
+            <a:ext cx="2057400" cy="320040"/>
           </a:xfrm>
           <a:prstGeom prst="rect">
             <a:avLst/>
@@ -8149,12 +7912,48 @@
               <a:buNone/>
             </a:pPr>
             <a:r>
+              <a:rPr lang="en-US" sz="1600" b="1" dirty="0">
+                <a:solidFill>
+                  <a:schemeClr val="tx1"/>
+                </a:solidFill>
+              </a:rPr>
+              <a:t>don't book</a:t>
+            </a:r>
+            <a:endParaRPr lang="en-US" sz="1600" dirty="0"/>
+          </a:p>
+        </p:txBody>
+      </p:sp>
+      <p:sp>
+        <p:nvSpPr>
+          <p:cNvPr id="14" name="Text 12"/>
+          <p:cNvSpPr txBox="1"/>
+          <p:nvPr/>
+        </p:nvSpPr>
+        <p:spPr>
+          <a:xfrm>
+            <a:off x="3657600" y="2926080"/>
+            <a:ext cx="2057400" cy="457200"/>
+          </a:xfrm>
+          <a:prstGeom prst="rect">
+            <a:avLst/>
+          </a:prstGeom>
+          <a:noFill/>
+          <a:ln/>
+        </p:spPr>
+        <p:txBody>
+          <a:bodyPr wrap="square" lIns="0" tIns="0" rIns="0" bIns="0" rtlCol="0" anchor="t"/>
+          <a:lstStyle/>
+          <a:p>
+            <a:pPr indent="0" marL="0">
+              <a:buNone/>
+            </a:pPr>
+            <a:r>
               <a:rPr lang="en-US" sz="1200" dirty="0">
                 <a:solidFill>
                   <a:schemeClr val="tx2"/>
                 </a:solidFill>
               </a:rPr>
-              <a:t>enquiries not booked a month</a:t>
+              <a:t>if 4 in 10 book today</a:t>
             </a:r>
             <a:endParaRPr lang="en-US" sz="1200" dirty="0"/>
           </a:p>
@@ -8162,18 +7961,326 @@
       </p:sp>
       <p:sp>
         <p:nvSpPr>
-          <p:cNvPr id="15" name="tile-1"/>
-          <p:cNvSpPr/>
-          <p:nvPr/>
-        </p:nvSpPr>
-        <p:spPr>
-          <a:xfrm>
-            <a:off x="9144000" y="2286000"/>
-            <a:ext cx="2423160" cy="1645920"/>
+          <p:cNvPr id="15" name="Shape 13"/>
+          <p:cNvSpPr/>
+          <p:nvPr/>
+        </p:nvSpPr>
+        <p:spPr>
+          <a:xfrm>
+            <a:off x="5925312" y="2560320"/>
+            <a:ext cx="265176" cy="0"/>
+          </a:xfrm>
+          <a:prstGeom prst="line">
+            <a:avLst/>
+          </a:prstGeom>
+          <a:noFill/>
+          <a:ln w="15875">
+            <a:solidFill>
+              <a:schemeClr val="tx2"/>
+            </a:solidFill>
+            <a:prstDash val="solid"/>
+            <a:tailEnd type="triangle"/>
+          </a:ln>
+        </p:spPr>
+      </p:sp>
+      <p:sp>
+        <p:nvSpPr>
+          <p:cNvPr id="16" name="chain-2"/>
+          <p:cNvSpPr/>
+          <p:nvPr/>
+        </p:nvSpPr>
+        <p:spPr>
+          <a:xfrm>
+            <a:off x="6217920" y="1600200"/>
+            <a:ext cx="2514600" cy="1920240"/>
           </a:xfrm>
           <a:prstGeom prst="roundRect">
             <a:avLst>
-              <a:gd name="adj" fmla="val 6667"/>
+              <a:gd name="adj" fmla="val 5714"/>
+            </a:avLst>
+          </a:prstGeom>
+          <a:solidFill>
+            <a:schemeClr val="accent4"/>
+          </a:solidFill>
+          <a:ln/>
+        </p:spPr>
+      </p:sp>
+      <p:sp>
+        <p:nvSpPr>
+          <p:cNvPr id="17" name="Text 15"/>
+          <p:cNvSpPr txBox="1"/>
+          <p:nvPr/>
+        </p:nvSpPr>
+        <p:spPr>
+          <a:xfrm>
+            <a:off x="6492240" y="1783080"/>
+            <a:ext cx="2057400" cy="777240"/>
+          </a:xfrm>
+          <a:prstGeom prst="rect">
+            <a:avLst/>
+          </a:prstGeom>
+          <a:noFill/>
+          <a:ln/>
+        </p:spPr>
+        <p:txBody>
+          <a:bodyPr wrap="square" lIns="0" tIns="0" rIns="0" bIns="0" rtlCol="0" anchor="b"/>
+          <a:lstStyle/>
+          <a:p>
+            <a:pPr indent="0" marL="0">
+              <a:buNone/>
+            </a:pPr>
+            <a:r>
+              <a:rPr lang="en-US" sz="4400" b="1" dirty="0">
+                <a:solidFill>
+                  <a:schemeClr val="tx1"/>
+                </a:solidFill>
+              </a:rPr>
+              <a:t>12</a:t>
+            </a:r>
+            <a:endParaRPr lang="en-US" sz="4400" dirty="0"/>
+          </a:p>
+        </p:txBody>
+      </p:sp>
+      <p:sp>
+        <p:nvSpPr>
+          <p:cNvPr id="18" name="Text 16"/>
+          <p:cNvSpPr txBox="1"/>
+          <p:nvPr/>
+        </p:nvSpPr>
+        <p:spPr>
+          <a:xfrm>
+            <a:off x="6492240" y="2606040"/>
+            <a:ext cx="2057400" cy="320040"/>
+          </a:xfrm>
+          <a:prstGeom prst="rect">
+            <a:avLst/>
+          </a:prstGeom>
+          <a:noFill/>
+          <a:ln/>
+        </p:spPr>
+        <p:txBody>
+          <a:bodyPr wrap="square" lIns="0" tIns="0" rIns="0" bIns="0" rtlCol="0" anchor="t"/>
+          <a:lstStyle/>
+          <a:p>
+            <a:pPr indent="0" marL="0">
+              <a:buNone/>
+            </a:pPr>
+            <a:r>
+              <a:rPr lang="en-US" sz="1600" b="1" dirty="0">
+                <a:solidFill>
+                  <a:schemeClr val="tx1"/>
+                </a:solidFill>
+              </a:rPr>
+              <a:t>brought back</a:t>
+            </a:r>
+            <a:endParaRPr lang="en-US" sz="1600" dirty="0"/>
+          </a:p>
+        </p:txBody>
+      </p:sp>
+      <p:sp>
+        <p:nvSpPr>
+          <p:cNvPr id="19" name="Text 17"/>
+          <p:cNvSpPr txBox="1"/>
+          <p:nvPr/>
+        </p:nvSpPr>
+        <p:spPr>
+          <a:xfrm>
+            <a:off x="6492240" y="2926080"/>
+            <a:ext cx="2057400" cy="457200"/>
+          </a:xfrm>
+          <a:prstGeom prst="rect">
+            <a:avLst/>
+          </a:prstGeom>
+          <a:noFill/>
+          <a:ln/>
+        </p:spPr>
+        <p:txBody>
+          <a:bodyPr wrap="square" lIns="0" tIns="0" rIns="0" bIns="0" rtlCol="0" anchor="t"/>
+          <a:lstStyle/>
+          <a:p>
+            <a:pPr indent="0" marL="0">
+              <a:buNone/>
+            </a:pPr>
+            <a:r>
+              <a:rPr lang="en-US" sz="1200" dirty="0">
+                <a:solidFill>
+                  <a:schemeClr val="accent1"/>
+                </a:solidFill>
+              </a:rPr>
+              <a:t>your receptionist wins back 1 in 5</a:t>
+            </a:r>
+            <a:endParaRPr lang="en-US" sz="1200" dirty="0"/>
+          </a:p>
+        </p:txBody>
+      </p:sp>
+      <p:sp>
+        <p:nvSpPr>
+          <p:cNvPr id="20" name="Shape 18"/>
+          <p:cNvSpPr/>
+          <p:nvPr/>
+        </p:nvSpPr>
+        <p:spPr>
+          <a:xfrm>
+            <a:off x="8759952" y="2560320"/>
+            <a:ext cx="265176" cy="0"/>
+          </a:xfrm>
+          <a:prstGeom prst="line">
+            <a:avLst/>
+          </a:prstGeom>
+          <a:noFill/>
+          <a:ln w="15875">
+            <a:solidFill>
+              <a:schemeClr val="tx2"/>
+            </a:solidFill>
+            <a:prstDash val="solid"/>
+            <a:tailEnd type="triangle"/>
+          </a:ln>
+        </p:spPr>
+      </p:sp>
+      <p:sp>
+        <p:nvSpPr>
+          <p:cNvPr id="21" name="chain-3"/>
+          <p:cNvSpPr/>
+          <p:nvPr/>
+        </p:nvSpPr>
+        <p:spPr>
+          <a:xfrm>
+            <a:off x="9052560" y="1600200"/>
+            <a:ext cx="2514600" cy="1920240"/>
+          </a:xfrm>
+          <a:prstGeom prst="roundRect">
+            <a:avLst>
+              <a:gd name="adj" fmla="val 5714"/>
+            </a:avLst>
+          </a:prstGeom>
+          <a:solidFill>
+            <a:schemeClr val="accent1"/>
+          </a:solidFill>
+          <a:ln/>
+        </p:spPr>
+      </p:sp>
+      <p:sp>
+        <p:nvSpPr>
+          <p:cNvPr id="22" name="Text 20"/>
+          <p:cNvSpPr txBox="1"/>
+          <p:nvPr/>
+        </p:nvSpPr>
+        <p:spPr>
+          <a:xfrm>
+            <a:off x="9326880" y="1783080"/>
+            <a:ext cx="2057400" cy="777240"/>
+          </a:xfrm>
+          <a:prstGeom prst="rect">
+            <a:avLst/>
+          </a:prstGeom>
+          <a:noFill/>
+          <a:ln/>
+        </p:spPr>
+        <p:txBody>
+          <a:bodyPr wrap="square" lIns="0" tIns="0" rIns="0" bIns="0" rtlCol="0" anchor="b"/>
+          <a:lstStyle/>
+          <a:p>
+            <a:pPr indent="0" marL="0">
+              <a:buNone/>
+            </a:pPr>
+            <a:r>
+              <a:rPr lang="en-US" sz="3400" b="1" dirty="0">
+                <a:solidFill>
+                  <a:schemeClr val="bg1"/>
+                </a:solidFill>
+              </a:rPr>
+              <a:t>₹96,000</a:t>
+            </a:r>
+            <a:endParaRPr lang="en-US" sz="3400" dirty="0"/>
+          </a:p>
+        </p:txBody>
+      </p:sp>
+      <p:sp>
+        <p:nvSpPr>
+          <p:cNvPr id="23" name="Text 21"/>
+          <p:cNvSpPr txBox="1"/>
+          <p:nvPr/>
+        </p:nvSpPr>
+        <p:spPr>
+          <a:xfrm>
+            <a:off x="9326880" y="2606040"/>
+            <a:ext cx="2057400" cy="320040"/>
+          </a:xfrm>
+          <a:prstGeom prst="rect">
+            <a:avLst/>
+          </a:prstGeom>
+          <a:noFill/>
+          <a:ln/>
+        </p:spPr>
+        <p:txBody>
+          <a:bodyPr wrap="square" lIns="0" tIns="0" rIns="0" bIns="0" rtlCol="0" anchor="t"/>
+          <a:lstStyle/>
+          <a:p>
+            <a:pPr indent="0" marL="0">
+              <a:buNone/>
+            </a:pPr>
+            <a:r>
+              <a:rPr lang="en-US" sz="1600" b="1" dirty="0">
+                <a:solidFill>
+                  <a:schemeClr val="bg1"/>
+                </a:solidFill>
+              </a:rPr>
+              <a:t>a month</a:t>
+            </a:r>
+            <a:endParaRPr lang="en-US" sz="1600" dirty="0"/>
+          </a:p>
+        </p:txBody>
+      </p:sp>
+      <p:sp>
+        <p:nvSpPr>
+          <p:cNvPr id="24" name="Text 22"/>
+          <p:cNvSpPr txBox="1"/>
+          <p:nvPr/>
+        </p:nvSpPr>
+        <p:spPr>
+          <a:xfrm>
+            <a:off x="9326880" y="2926080"/>
+            <a:ext cx="2057400" cy="457200"/>
+          </a:xfrm>
+          <a:prstGeom prst="rect">
+            <a:avLst/>
+          </a:prstGeom>
+          <a:noFill/>
+          <a:ln/>
+        </p:spPr>
+        <p:txBody>
+          <a:bodyPr wrap="square" lIns="0" tIns="0" rIns="0" bIns="0" rtlCol="0" anchor="t"/>
+          <a:lstStyle/>
+          <a:p>
+            <a:pPr indent="0" marL="0">
+              <a:buNone/>
+            </a:pPr>
+            <a:r>
+              <a:rPr lang="en-US" sz="1200" dirty="0">
+                <a:solidFill>
+                  <a:schemeClr val="bg1"/>
+                </a:solidFill>
+              </a:rPr>
+              <a:t>12 patients × ₹8,000</a:t>
+            </a:r>
+            <a:endParaRPr lang="en-US" sz="1200" dirty="0"/>
+          </a:p>
+        </p:txBody>
+      </p:sp>
+      <p:sp>
+        <p:nvSpPr>
+          <p:cNvPr id="25" name="per-patient"/>
+          <p:cNvSpPr/>
+          <p:nvPr/>
+        </p:nvSpPr>
+        <p:spPr>
+          <a:xfrm>
+            <a:off x="548640" y="3794760"/>
+            <a:ext cx="7315200" cy="2194560"/>
+          </a:xfrm>
+          <a:prstGeom prst="roundRect">
+            <a:avLst>
+              <a:gd name="adj" fmla="val 5000"/>
             </a:avLst>
           </a:prstGeom>
           <a:solidFill>
@@ -8189,149 +8296,108 @@
       </p:sp>
       <p:sp>
         <p:nvSpPr>
-          <p:cNvPr id="16" name="Text 12"/>
+          <p:cNvPr id="26" name="Text 24"/>
           <p:cNvSpPr txBox="1"/>
           <p:nvPr/>
         </p:nvSpPr>
         <p:spPr>
           <a:xfrm>
-            <a:off x="9372600" y="2450592"/>
-            <a:ext cx="2011680" cy="640080"/>
-          </a:xfrm>
-          <a:prstGeom prst="rect">
-            <a:avLst/>
-          </a:prstGeom>
-          <a:noFill/>
-          <a:ln/>
-        </p:spPr>
-        <p:txBody>
-          <a:bodyPr wrap="square" lIns="0" tIns="0" rIns="0" bIns="0" rtlCol="0" anchor="b"/>
+            <a:off x="868680" y="4023360"/>
+            <a:ext cx="6400800" cy="274320"/>
+          </a:xfrm>
+          <a:prstGeom prst="rect">
+            <a:avLst/>
+          </a:prstGeom>
+          <a:noFill/>
+          <a:ln/>
+        </p:spPr>
+        <p:txBody>
+          <a:bodyPr wrap="square" lIns="0" tIns="0" rIns="0" bIns="0" rtlCol="0" anchor="t"/>
           <a:lstStyle/>
           <a:p>
             <a:pPr indent="0" marL="0">
               <a:buNone/>
             </a:pPr>
             <a:r>
-              <a:rPr lang="en-US" sz="3000" b="1" dirty="0">
-                <a:solidFill>
-                  <a:schemeClr val="tx1"/>
-                </a:solidFill>
-              </a:rPr>
-              <a:t>₹8,000</a:t>
-            </a:r>
-            <a:endParaRPr lang="en-US" sz="3000" dirty="0"/>
-          </a:p>
-        </p:txBody>
-      </p:sp>
-      <p:sp>
-        <p:nvSpPr>
-          <p:cNvPr id="17" name="Text 13"/>
-          <p:cNvSpPr txBox="1"/>
-          <p:nvPr/>
-        </p:nvSpPr>
-        <p:spPr>
-          <a:xfrm>
-            <a:off x="9372600" y="3154680"/>
-            <a:ext cx="2011680" cy="685800"/>
-          </a:xfrm>
-          <a:prstGeom prst="rect">
-            <a:avLst/>
-          </a:prstGeom>
-          <a:noFill/>
-          <a:ln/>
-        </p:spPr>
-        <p:txBody>
-          <a:bodyPr wrap="square" lIns="0" tIns="0" rIns="0" bIns="0" rtlCol="0" anchor="t"/>
-          <a:lstStyle/>
-          <a:p>
-            <a:pPr indent="0" marL="0">
-              <a:buNone/>
-            </a:pPr>
-            <a:r>
-              <a:rPr lang="en-US" sz="1200" dirty="0">
-                <a:solidFill>
-                  <a:schemeClr val="tx2"/>
-                </a:solidFill>
-              </a:rPr>
-              <a:t>value of one booked patient</a:t>
-            </a:r>
-            <a:endParaRPr lang="en-US" sz="1200" dirty="0"/>
-          </a:p>
-        </p:txBody>
-      </p:sp>
-      <p:sp>
-        <p:nvSpPr>
-          <p:cNvPr id="18" name="tile-2"/>
-          <p:cNvSpPr/>
-          <p:nvPr/>
-        </p:nvSpPr>
-        <p:spPr>
-          <a:xfrm>
-            <a:off x="6583680" y="4096512"/>
-            <a:ext cx="2423160" cy="1645920"/>
+              <a:rPr lang="en-US" sz="1100" b="1" spc="150" kern="0" dirty="0">
+                <a:solidFill>
+                  <a:schemeClr val="accent1"/>
+                </a:solidFill>
+              </a:rPr>
+              <a:t>WHAT ONE BOOKED PATIENT IS WORTH</a:t>
+            </a:r>
+            <a:endParaRPr lang="en-US" sz="1100" dirty="0"/>
+          </a:p>
+        </p:txBody>
+      </p:sp>
+      <p:sp>
+        <p:nvSpPr>
+          <p:cNvPr id="27" name="Shape 25"/>
+          <p:cNvSpPr/>
+          <p:nvPr/>
+        </p:nvSpPr>
+        <p:spPr>
+          <a:xfrm>
+            <a:off x="868680" y="4434840"/>
+            <a:ext cx="1874520" cy="1280160"/>
           </a:xfrm>
           <a:prstGeom prst="roundRect">
             <a:avLst>
-              <a:gd name="adj" fmla="val 6667"/>
+              <a:gd name="adj" fmla="val 7143"/>
             </a:avLst>
           </a:prstGeom>
           <a:solidFill>
-            <a:schemeClr val="bg1"/>
+            <a:schemeClr val="bg2"/>
           </a:solidFill>
-          <a:ln w="9525">
-            <a:solidFill>
-              <a:srgbClr val="D5DEDB"/>
-            </a:solidFill>
-            <a:prstDash val="solid"/>
-          </a:ln>
-        </p:spPr>
-      </p:sp>
-      <p:sp>
-        <p:nvSpPr>
-          <p:cNvPr id="19" name="Text 15"/>
+          <a:ln/>
+        </p:spPr>
+      </p:sp>
+      <p:sp>
+        <p:nvSpPr>
+          <p:cNvPr id="28" name="Text 26"/>
           <p:cNvSpPr txBox="1"/>
           <p:nvPr/>
         </p:nvSpPr>
         <p:spPr>
           <a:xfrm>
-            <a:off x="6812280" y="4261104"/>
-            <a:ext cx="2011680" cy="640080"/>
-          </a:xfrm>
-          <a:prstGeom prst="rect">
-            <a:avLst/>
-          </a:prstGeom>
-          <a:noFill/>
-          <a:ln/>
-        </p:spPr>
-        <p:txBody>
-          <a:bodyPr wrap="square" lIns="0" tIns="0" rIns="0" bIns="0" rtlCol="0" anchor="b"/>
+            <a:off x="1051560" y="4553712"/>
+            <a:ext cx="1554480" cy="548640"/>
+          </a:xfrm>
+          <a:prstGeom prst="rect">
+            <a:avLst/>
+          </a:prstGeom>
+          <a:noFill/>
+          <a:ln/>
+        </p:spPr>
+        <p:txBody>
+          <a:bodyPr wrap="square" lIns="0" tIns="0" rIns="0" bIns="0" rtlCol="0" anchor="ctr"/>
           <a:lstStyle/>
           <a:p>
             <a:pPr indent="0" marL="0">
               <a:buNone/>
             </a:pPr>
             <a:r>
-              <a:rPr lang="en-US" sz="3000" b="1" dirty="0">
+              <a:rPr lang="en-US" sz="2600" b="1" dirty="0">
                 <a:solidFill>
                   <a:schemeClr val="tx1"/>
                 </a:solidFill>
               </a:rPr>
-              <a:t>₹96,000</a:t>
-            </a:r>
-            <a:endParaRPr lang="en-US" sz="3000" dirty="0"/>
-          </a:p>
-        </p:txBody>
-      </p:sp>
-      <p:sp>
-        <p:nvSpPr>
-          <p:cNvPr id="20" name="Text 16"/>
+              <a:t>₹500</a:t>
+            </a:r>
+            <a:endParaRPr lang="en-US" sz="2600" dirty="0"/>
+          </a:p>
+        </p:txBody>
+      </p:sp>
+      <p:sp>
+        <p:nvSpPr>
+          <p:cNvPr id="29" name="Text 27"/>
           <p:cNvSpPr txBox="1"/>
           <p:nvPr/>
         </p:nvSpPr>
         <p:spPr>
           <a:xfrm>
-            <a:off x="6812280" y="4965192"/>
-            <a:ext cx="2011680" cy="685800"/>
+            <a:off x="1051560" y="5120640"/>
+            <a:ext cx="1600200" cy="548640"/>
           </a:xfrm>
           <a:prstGeom prst="rect">
             <a:avLst/>
@@ -8352,7 +8418,7 @@
                   <a:schemeClr val="tx2"/>
                 </a:solidFill>
               </a:rPr>
-              <a:t>revenue recovered a month from 12 patients brought back</a:t>
+              <a:t>consultation fee</a:t>
             </a:r>
             <a:endParaRPr lang="en-US" sz="1200" dirty="0"/>
           </a:p>
@@ -8360,36 +8426,296 @@
       </p:sp>
       <p:sp>
         <p:nvSpPr>
-          <p:cNvPr id="21" name="tile-3"/>
-          <p:cNvSpPr/>
-          <p:nvPr/>
-        </p:nvSpPr>
-        <p:spPr>
-          <a:xfrm>
-            <a:off x="9144000" y="4096512"/>
-            <a:ext cx="2423160" cy="1645920"/>
+          <p:cNvPr id="30" name="Text 28"/>
+          <p:cNvSpPr txBox="1"/>
+          <p:nvPr/>
+        </p:nvSpPr>
+        <p:spPr>
+          <a:xfrm>
+            <a:off x="2743200" y="4754880"/>
+            <a:ext cx="457200" cy="548640"/>
+          </a:xfrm>
+          <a:prstGeom prst="rect">
+            <a:avLst/>
+          </a:prstGeom>
+          <a:noFill/>
+          <a:ln/>
+        </p:spPr>
+        <p:txBody>
+          <a:bodyPr wrap="square" lIns="0" tIns="0" rIns="0" bIns="0" rtlCol="0" anchor="ctr"/>
+          <a:lstStyle/>
+          <a:p>
+            <a:pPr algn="ctr" indent="0" marL="0">
+              <a:buNone/>
+            </a:pPr>
+            <a:r>
+              <a:rPr lang="en-US" sz="2600" b="1" dirty="0">
+                <a:solidFill>
+                  <a:schemeClr val="tx2"/>
+                </a:solidFill>
+              </a:rPr>
+              <a:t>+</a:t>
+            </a:r>
+            <a:endParaRPr lang="en-US" sz="2600" dirty="0"/>
+          </a:p>
+        </p:txBody>
+      </p:sp>
+      <p:sp>
+        <p:nvSpPr>
+          <p:cNvPr id="31" name="Shape 29"/>
+          <p:cNvSpPr/>
+          <p:nvPr/>
+        </p:nvSpPr>
+        <p:spPr>
+          <a:xfrm>
+            <a:off x="3200400" y="4434840"/>
+            <a:ext cx="1874520" cy="1280160"/>
           </a:xfrm>
           <a:prstGeom prst="roundRect">
             <a:avLst>
-              <a:gd name="adj" fmla="val 6667"/>
+              <a:gd name="adj" fmla="val 7143"/>
             </a:avLst>
           </a:prstGeom>
           <a:solidFill>
-            <a:schemeClr val="accent1"/>
+            <a:schemeClr val="bg2"/>
           </a:solidFill>
           <a:ln/>
         </p:spPr>
       </p:sp>
       <p:sp>
         <p:nvSpPr>
-          <p:cNvPr id="22" name="Text 18"/>
+          <p:cNvPr id="32" name="Text 30"/>
           <p:cNvSpPr txBox="1"/>
           <p:nvPr/>
         </p:nvSpPr>
         <p:spPr>
           <a:xfrm>
-            <a:off x="9372600" y="4261104"/>
-            <a:ext cx="2011680" cy="640080"/>
+            <a:off x="3383280" y="4553712"/>
+            <a:ext cx="1554480" cy="548640"/>
+          </a:xfrm>
+          <a:prstGeom prst="rect">
+            <a:avLst/>
+          </a:prstGeom>
+          <a:noFill/>
+          <a:ln/>
+        </p:spPr>
+        <p:txBody>
+          <a:bodyPr wrap="square" lIns="0" tIns="0" rIns="0" bIns="0" rtlCol="0" anchor="ctr"/>
+          <a:lstStyle/>
+          <a:p>
+            <a:pPr indent="0" marL="0">
+              <a:buNone/>
+            </a:pPr>
+            <a:r>
+              <a:rPr lang="en-US" sz="2600" b="1" dirty="0">
+                <a:solidFill>
+                  <a:schemeClr val="tx1"/>
+                </a:solidFill>
+              </a:rPr>
+              <a:t>₹7,500</a:t>
+            </a:r>
+            <a:endParaRPr lang="en-US" sz="2600" dirty="0"/>
+          </a:p>
+        </p:txBody>
+      </p:sp>
+      <p:sp>
+        <p:nvSpPr>
+          <p:cNvPr id="33" name="Text 31"/>
+          <p:cNvSpPr txBox="1"/>
+          <p:nvPr/>
+        </p:nvSpPr>
+        <p:spPr>
+          <a:xfrm>
+            <a:off x="3383280" y="5120640"/>
+            <a:ext cx="1600200" cy="548640"/>
+          </a:xfrm>
+          <a:prstGeom prst="rect">
+            <a:avLst/>
+          </a:prstGeom>
+          <a:noFill/>
+          <a:ln/>
+        </p:spPr>
+        <p:txBody>
+          <a:bodyPr wrap="square" lIns="0" tIns="0" rIns="0" bIns="0" rtlCol="0" anchor="t"/>
+          <a:lstStyle/>
+          <a:p>
+            <a:pPr indent="0" marL="0">
+              <a:buNone/>
+            </a:pPr>
+            <a:r>
+              <a:rPr lang="en-US" sz="1200" dirty="0">
+                <a:solidFill>
+                  <a:schemeClr val="tx2"/>
+                </a:solidFill>
+              </a:rPr>
+              <a:t>half go on to ₹15,000 treatment</a:t>
+            </a:r>
+            <a:endParaRPr lang="en-US" sz="1200" dirty="0"/>
+          </a:p>
+        </p:txBody>
+      </p:sp>
+      <p:sp>
+        <p:nvSpPr>
+          <p:cNvPr id="34" name="Text 32"/>
+          <p:cNvSpPr txBox="1"/>
+          <p:nvPr/>
+        </p:nvSpPr>
+        <p:spPr>
+          <a:xfrm>
+            <a:off x="5074920" y="4754880"/>
+            <a:ext cx="457200" cy="548640"/>
+          </a:xfrm>
+          <a:prstGeom prst="rect">
+            <a:avLst/>
+          </a:prstGeom>
+          <a:noFill/>
+          <a:ln/>
+        </p:spPr>
+        <p:txBody>
+          <a:bodyPr wrap="square" lIns="0" tIns="0" rIns="0" bIns="0" rtlCol="0" anchor="ctr"/>
+          <a:lstStyle/>
+          <a:p>
+            <a:pPr algn="ctr" indent="0" marL="0">
+              <a:buNone/>
+            </a:pPr>
+            <a:r>
+              <a:rPr lang="en-US" sz="2600" b="1" dirty="0">
+                <a:solidFill>
+                  <a:schemeClr val="tx2"/>
+                </a:solidFill>
+              </a:rPr>
+              <a:t>=</a:t>
+            </a:r>
+            <a:endParaRPr lang="en-US" sz="2600" dirty="0"/>
+          </a:p>
+        </p:txBody>
+      </p:sp>
+      <p:sp>
+        <p:nvSpPr>
+          <p:cNvPr id="35" name="Shape 33"/>
+          <p:cNvSpPr/>
+          <p:nvPr/>
+        </p:nvSpPr>
+        <p:spPr>
+          <a:xfrm>
+            <a:off x="5532120" y="4434840"/>
+            <a:ext cx="1874520" cy="1280160"/>
+          </a:xfrm>
+          <a:prstGeom prst="roundRect">
+            <a:avLst>
+              <a:gd name="adj" fmla="val 7143"/>
+            </a:avLst>
+          </a:prstGeom>
+          <a:solidFill>
+            <a:schemeClr val="accent4"/>
+          </a:solidFill>
+          <a:ln/>
+        </p:spPr>
+      </p:sp>
+      <p:sp>
+        <p:nvSpPr>
+          <p:cNvPr id="36" name="Text 34"/>
+          <p:cNvSpPr txBox="1"/>
+          <p:nvPr/>
+        </p:nvSpPr>
+        <p:spPr>
+          <a:xfrm>
+            <a:off x="5715000" y="4553712"/>
+            <a:ext cx="1554480" cy="548640"/>
+          </a:xfrm>
+          <a:prstGeom prst="rect">
+            <a:avLst/>
+          </a:prstGeom>
+          <a:noFill/>
+          <a:ln/>
+        </p:spPr>
+        <p:txBody>
+          <a:bodyPr wrap="square" lIns="0" tIns="0" rIns="0" bIns="0" rtlCol="0" anchor="ctr"/>
+          <a:lstStyle/>
+          <a:p>
+            <a:pPr indent="0" marL="0">
+              <a:buNone/>
+            </a:pPr>
+            <a:r>
+              <a:rPr lang="en-US" sz="2600" b="1" dirty="0">
+                <a:solidFill>
+                  <a:schemeClr val="accent1"/>
+                </a:solidFill>
+              </a:rPr>
+              <a:t>₹8,000</a:t>
+            </a:r>
+            <a:endParaRPr lang="en-US" sz="2600" dirty="0"/>
+          </a:p>
+        </p:txBody>
+      </p:sp>
+      <p:sp>
+        <p:nvSpPr>
+          <p:cNvPr id="37" name="Text 35"/>
+          <p:cNvSpPr txBox="1"/>
+          <p:nvPr/>
+        </p:nvSpPr>
+        <p:spPr>
+          <a:xfrm>
+            <a:off x="5715000" y="5120640"/>
+            <a:ext cx="1600200" cy="548640"/>
+          </a:xfrm>
+          <a:prstGeom prst="rect">
+            <a:avLst/>
+          </a:prstGeom>
+          <a:noFill/>
+          <a:ln/>
+        </p:spPr>
+        <p:txBody>
+          <a:bodyPr wrap="square" lIns="0" tIns="0" rIns="0" bIns="0" rtlCol="0" anchor="t"/>
+          <a:lstStyle/>
+          <a:p>
+            <a:pPr indent="0" marL="0">
+              <a:buNone/>
+            </a:pPr>
+            <a:r>
+              <a:rPr lang="en-US" sz="1200" dirty="0">
+                <a:solidFill>
+                  <a:schemeClr val="tx2"/>
+                </a:solidFill>
+              </a:rPr>
+              <a:t>per booked patient</a:t>
+            </a:r>
+            <a:endParaRPr lang="en-US" sz="1200" dirty="0"/>
+          </a:p>
+        </p:txBody>
+      </p:sp>
+      <p:sp>
+        <p:nvSpPr>
+          <p:cNvPr id="38" name="covers-fee"/>
+          <p:cNvSpPr/>
+          <p:nvPr/>
+        </p:nvSpPr>
+        <p:spPr>
+          <a:xfrm>
+            <a:off x="8092440" y="3794760"/>
+            <a:ext cx="3547872" cy="2194560"/>
+          </a:xfrm>
+          <a:prstGeom prst="roundRect">
+            <a:avLst>
+              <a:gd name="adj" fmla="val 5000"/>
+            </a:avLst>
+          </a:prstGeom>
+          <a:solidFill>
+            <a:schemeClr val="tx1"/>
+          </a:solidFill>
+          <a:ln/>
+        </p:spPr>
+      </p:sp>
+      <p:sp>
+        <p:nvSpPr>
+          <p:cNvPr id="39" name="Text 37"/>
+          <p:cNvSpPr txBox="1"/>
+          <p:nvPr/>
+        </p:nvSpPr>
+        <p:spPr>
+          <a:xfrm>
+            <a:off x="8412480" y="4069080"/>
+            <a:ext cx="3017520" cy="731520"/>
           </a:xfrm>
           <a:prstGeom prst="rect">
             <a:avLst/>
@@ -8405,50 +8731,50 @@
               <a:buNone/>
             </a:pPr>
             <a:r>
-              <a:rPr lang="en-US" sz="3000" b="1" dirty="0">
+              <a:rPr lang="en-US" sz="4000" b="1" dirty="0">
+                <a:solidFill>
+                  <a:schemeClr val="accent2"/>
+                </a:solidFill>
+              </a:rPr>
+              <a:t>1 patient</a:t>
+            </a:r>
+            <a:endParaRPr lang="en-US" sz="4000" dirty="0"/>
+          </a:p>
+        </p:txBody>
+      </p:sp>
+      <p:sp>
+        <p:nvSpPr>
+          <p:cNvPr id="40" name="Text 38"/>
+          <p:cNvSpPr txBox="1"/>
+          <p:nvPr/>
+        </p:nvSpPr>
+        <p:spPr>
+          <a:xfrm>
+            <a:off x="8412480" y="4892040"/>
+            <a:ext cx="2926080" cy="822960"/>
+          </a:xfrm>
+          <a:prstGeom prst="rect">
+            <a:avLst/>
+          </a:prstGeom>
+          <a:noFill/>
+          <a:ln/>
+        </p:spPr>
+        <p:txBody>
+          <a:bodyPr wrap="square" lIns="0" tIns="0" rIns="0" bIns="0" rtlCol="0" anchor="t"/>
+          <a:lstStyle/>
+          <a:p>
+            <a:pPr indent="0" marL="0">
+              <a:buNone/>
+            </a:pPr>
+            <a:r>
+              <a:rPr lang="en-US" sz="1500" dirty="0">
                 <a:solidFill>
                   <a:schemeClr val="bg1"/>
                 </a:solidFill>
               </a:rPr>
-              <a:t>1 patient</a:t>
-            </a:r>
-            <a:endParaRPr lang="en-US" sz="3000" dirty="0"/>
-          </a:p>
-        </p:txBody>
-      </p:sp>
-      <p:sp>
-        <p:nvSpPr>
-          <p:cNvPr id="23" name="Text 19"/>
-          <p:cNvSpPr txBox="1"/>
-          <p:nvPr/>
-        </p:nvSpPr>
-        <p:spPr>
-          <a:xfrm>
-            <a:off x="9372600" y="4965192"/>
-            <a:ext cx="2011680" cy="685800"/>
-          </a:xfrm>
-          <a:prstGeom prst="rect">
-            <a:avLst/>
-          </a:prstGeom>
-          <a:noFill/>
-          <a:ln/>
-        </p:spPr>
-        <p:txBody>
-          <a:bodyPr wrap="square" lIns="0" tIns="0" rIns="0" bIns="0" rtlCol="0" anchor="t"/>
-          <a:lstStyle/>
-          <a:p>
-            <a:pPr indent="0" marL="0">
-              <a:buNone/>
-            </a:pPr>
-            <a:r>
-              <a:rPr lang="en-US" sz="1200" dirty="0">
-                <a:solidFill>
-                  <a:schemeClr val="bg1"/>
-                </a:solidFill>
-              </a:rPr>
-              <a:t>a month covers the ₹2,999 fee</a:t>
-            </a:r>
-            <a:endParaRPr lang="en-US" sz="1200" dirty="0"/>
+              <a:t>brought back a month covers the ₹2,999 monthly fee</a:t>
+            </a:r>
+            <a:endParaRPr lang="en-US" sz="1500" dirty="0"/>
           </a:p>
         </p:txBody>
       </p:sp>
@@ -8607,11 +8933,11 @@
         <p:spPr>
           <a:xfrm>
             <a:off x="548640" y="1600200"/>
-            <a:ext cx="3566160" cy="3657600"/>
+            <a:ext cx="3566160" cy="3383280"/>
           </a:xfrm>
           <a:prstGeom prst="roundRect">
             <a:avLst>
-              <a:gd name="adj" fmla="val 3077"/>
+              <a:gd name="adj" fmla="val 3243"/>
             </a:avLst>
           </a:prstGeom>
           <a:solidFill>
@@ -8806,11 +9132,11 @@
         <p:spPr>
           <a:xfrm>
             <a:off x="4297680" y="1600200"/>
-            <a:ext cx="3566160" cy="3657600"/>
+            <a:ext cx="3566160" cy="3383280"/>
           </a:xfrm>
           <a:prstGeom prst="roundRect">
             <a:avLst>
-              <a:gd name="adj" fmla="val 3077"/>
+              <a:gd name="adj" fmla="val 3243"/>
             </a:avLst>
           </a:prstGeom>
           <a:solidFill>
@@ -9005,11 +9331,11 @@
         <p:spPr>
           <a:xfrm>
             <a:off x="8046720" y="1600200"/>
-            <a:ext cx="3566160" cy="3657600"/>
+            <a:ext cx="3566160" cy="3383280"/>
           </a:xfrm>
           <a:prstGeom prst="roundRect">
             <a:avLst>
-              <a:gd name="adj" fmla="val 3077"/>
+              <a:gd name="adj" fmla="val 3243"/>
             </a:avLst>
           </a:prstGeom>
           <a:solidFill>

</xml_diff>